<commit_message>
Make v1.2.0 framework self-contained with formula-driven Summary sheet
- Summary sheet built into the xlsm (no VBA import): results table by
  category, verdict line, five charts, navigation buttons; View Summary
  button on General Information
- Output.bas moved to superseded/ (first-draft approach, not a deliverable)
- Change record: Section 7 rewritten, Appendix B formula reference,
  Appendix A Summary row, hashes refreshed
- Deck: new Summary sheet slide, updated usability, verification and
  closing slides
- build_summary.py added; patch_lcca.py transplants the Summary sheet
- MBT render of the populated Summary (PNG and PDF) for review

Co-Authored-By: Claude Fable 5.1 <noreply@anthropic.com>
Claude-Session: https://claude.ai/code/session_01JrCXNd278qC95SDvCCWbYM
</commit_message>
<xml_diff>
--- a/tdot-lcca/TDOT_LCCA_Review_and_v1.2.0_Update.pptx
+++ b/tdot-lcca/TDOT_LCCA_Review_and_v1.2.0_Update.pptx
@@ -24,9 +24,10 @@
     <p:sldId id="272" r:id="rId18"/>
     <p:sldId id="273" r:id="rId19"/>
     <p:sldId id="274" r:id="rId20"/>
+    <p:sldId id="275" r:id="rId21"/>
   </p:sldIdLst>
   <p:notesMasterIdLst>
-    <p:notesMasterId r:id="rId21"/>
+    <p:notesMasterId r:id="rId22"/>
   </p:notesMasterIdLst>
   <p:sldSz cx="9144000" cy="5143500"/>
   <p:notesSz cx="5143500" cy="9144000"/>
@@ -608,7 +609,7 @@
           <a:p>
             <a:r>
               <a:rPr lang="en-US" dirty="0"/>
-              <a:t>The Summary is rebuilt every time the Alternative Setup form closes, as before.</a:t>
+              <a:t>The Summary formulas read the Database sheet the form writes, so they follow whatever alternatives exist.</a:t>
             </a:r>
             <a:endParaRPr lang="en-US" dirty="0"/>
           </a:p>
@@ -696,7 +697,7 @@
           <a:p>
             <a:r>
               <a:rPr lang="en-US" dirty="0"/>
-              <a:t>Everything is a formula. Change the discount rate cell and the sensitivity, tornado, map and charts all move.</a:t>
+              <a:t/>
             </a:r>
             <a:endParaRPr lang="en-US" dirty="0"/>
           </a:p>
@@ -784,7 +785,7 @@
           <a:p>
             <a:r>
               <a:rPr lang="en-US" dirty="0"/>
-              <a:t>This is the chart Aeronautics asked for when they commissioned the lost-revenue update.</a:t>
+              <a:t>Everything is a formula. Change the discount rate cell and the sensitivity, tornado, map and charts all move.</a:t>
             </a:r>
             <a:endParaRPr lang="en-US" dirty="0"/>
           </a:p>
@@ -872,7 +873,7 @@
           <a:p>
             <a:r>
               <a:rPr lang="en-US" dirty="0"/>
-              <a:t>Break-even table on the sheet gives the exact tie points: PCC bids +9.9% or salvage below 2.5% of initial cost flips MBT.</a:t>
+              <a:t>This is the chart Aeronautics asked for when they commissioned the lost-revenue update.</a:t>
             </a:r>
             <a:endParaRPr lang="en-US" dirty="0"/>
           </a:p>
@@ -960,7 +961,7 @@
           <a:p>
             <a:r>
               <a:rPr lang="en-US" dirty="0"/>
-              <a:t>Break-even values come from the BREAK-EVEN VALUES block on the sheet, computed in closed form, no goal seek.</a:t>
+              <a:t>Break-even table on the sheet gives the exact tie points: PCC bids +9.9% or salvage below 2.5% of initial cost flips MBT.</a:t>
             </a:r>
             <a:endParaRPr lang="en-US" dirty="0"/>
           </a:p>
@@ -1048,7 +1049,7 @@
           <a:p>
             <a:r>
               <a:rPr lang="en-US" dirty="0"/>
-              <a:t>SRB break-even daily revenue is about $23,000 per day against $4,344 actual.</a:t>
+              <a:t>Break-even values come from the BREAK-EVEN VALUES block on the sheet, computed in closed form, no goal seek.</a:t>
             </a:r>
             <a:endParaRPr lang="en-US" dirty="0"/>
           </a:p>
@@ -1136,7 +1137,7 @@
           <a:p>
             <a:r>
               <a:rPr lang="en-US" dirty="0"/>
-              <a:t>The first-open check: pick an airport, set Yes, add one HMA and one PCC alternative, confirm Summary and Alt sheet columns L:N.</a:t>
+              <a:t>SRB break-even daily revenue is about $23,000 per day against $4,344 actual.</a:t>
             </a:r>
             <a:endParaRPr lang="en-US" dirty="0"/>
           </a:p>
@@ -1224,7 +1225,7 @@
           <a:p>
             <a:r>
               <a:rPr lang="en-US" dirty="0"/>
-              <a:t>Two alternatives per sheet, HMA against PCC, is how the framework is used; policy years are editable if TDOT revises the maintenance tables.</a:t>
+              <a:t>The first-open check: pick an airport, set Yes, add one HMA and one PCC alternative, confirm Summary and Alt sheet columns L:N.</a:t>
             </a:r>
             <a:endParaRPr lang="en-US" dirty="0"/>
           </a:p>
@@ -1312,7 +1313,7 @@
           <a:p>
             <a:r>
               <a:rPr lang="en-US" dirty="0"/>
-              <a:t>Keep it Excel-first; the web option is noted only because IT blocking was the reviewer's first obstacle.</a:t>
+              <a:t>Two alternatives per sheet, HMA against PCC, is how the framework is used; policy years are editable if TDOT revises the maintenance tables.</a:t>
             </a:r>
             <a:endParaRPr lang="en-US" dirty="0"/>
           </a:p>
@@ -1400,7 +1401,7 @@
           <a:p>
             <a:r>
               <a:rPr lang="en-US" dirty="0"/>
-              <a:t/>
+              <a:t>Keep it Excel-first; the web option is noted only because IT blocking was the reviewer's first obstacle.</a:t>
             </a:r>
             <a:endParaRPr lang="en-US" dirty="0"/>
           </a:p>
@@ -1512,6 +1513,94 @@
             <a:fld id="{F7021451-1387-4CA6-816F-3879F97B5CBC}" type="slidenum">
               <a:rPr lang="en-US"/>
               <a:t>2</a:t>
+            </a:fld>
+            <a:endParaRPr lang="en-US"/>
+          </a:p>
+        </p:txBody>
+      </p:sp>
+    </p:spTree>
+    <p:extLst>
+      <p:ext uri="{BB962C8B-B14F-4D97-AF65-F5344CB8AC3E}">
+        <p14:creationId xmlns:p14="http://schemas.microsoft.com/office/powerpoint/2010/main" val="1024086991"/>
+      </p:ext>
+    </p:extLst>
+  </p:cSld>
+  <p:clrMapOvr>
+    <a:masterClrMapping/>
+  </p:clrMapOvr>
+</p:notes>
+</file>
+
+<file path=ppt/notesSlides/notesSlide20.xml><?xml version="1.0" encoding="utf-8"?>
+<p:notes xmlns:a="http://schemas.openxmlformats.org/drawingml/2006/main" xmlns:r="http://schemas.openxmlformats.org/officeDocument/2006/relationships" xmlns:p="http://schemas.openxmlformats.org/presentationml/2006/main">
+  <p:cSld>
+    <p:spTree>
+      <p:nvGrpSpPr>
+        <p:cNvPr id="1" name=""/>
+        <p:cNvGrpSpPr/>
+        <p:nvPr/>
+      </p:nvGrpSpPr>
+      <p:grpSpPr>
+        <a:xfrm>
+          <a:off x="0" y="0"/>
+          <a:ext cx="0" cy="0"/>
+          <a:chOff x="0" y="0"/>
+          <a:chExt cx="0" cy="0"/>
+        </a:xfrm>
+      </p:grpSpPr>
+      <p:sp>
+        <p:nvSpPr>
+          <p:cNvPr id="2" name="Slide Image Placeholder 1"/>
+          <p:cNvSpPr>
+            <a:spLocks noGrp="1" noRot="1" noChangeAspect="1"/>
+          </p:cNvSpPr>
+          <p:nvPr>
+            <p:ph type="sldImg"/>
+          </p:nvPr>
+        </p:nvSpPr>
+        <p:spPr/>
+      </p:sp>
+      <p:sp>
+        <p:nvSpPr>
+          <p:cNvPr id="3" name="Notes Placeholder 2"/>
+          <p:cNvSpPr>
+            <a:spLocks noGrp="1"/>
+          </p:cNvSpPr>
+          <p:nvPr>
+            <p:ph type="body" idx="1"/>
+          </p:nvPr>
+        </p:nvSpPr>
+        <p:spPr/>
+        <p:txBody>
+          <a:bodyPr/>
+          <a:lstStyle/>
+          <a:p>
+            <a:r>
+              <a:rPr lang="en-US" dirty="0"/>
+              <a:t/>
+            </a:r>
+            <a:endParaRPr lang="en-US" dirty="0"/>
+          </a:p>
+        </p:txBody>
+      </p:sp>
+      <p:sp>
+        <p:nvSpPr>
+          <p:cNvPr id="4" name="Slide Number Placeholder 3"/>
+          <p:cNvSpPr>
+            <a:spLocks noGrp="1"/>
+          </p:cNvSpPr>
+          <p:nvPr>
+            <p:ph type="sldNum" sz="quarter" idx="10"/>
+          </p:nvPr>
+        </p:nvSpPr>
+        <p:spPr/>
+        <p:txBody>
+          <a:bodyPr/>
+          <a:lstStyle/>
+          <a:p>
+            <a:fld id="{F7021451-1387-4CA6-816F-3879F97B5CBC}" type="slidenum">
+              <a:rPr lang="en-US"/>
+              <a:t>20</a:t>
             </a:fld>
             <a:endParaRPr lang="en-US"/>
           </a:p>
@@ -3162,7 +3251,7 @@
                           <a:ea typeface="Calibri" pitchFamily="34" charset="-122"/>
                           <a:cs typeface="Calibri" pitchFamily="34" charset="-120"/>
                         </a:rPr>
-                        <a:t>Summary sheet (VBA)</a:t>
+                        <a:t>Summary sheet</a:t>
                       </a:r>
                       <a:endParaRPr lang="en-US" sz="1050" dirty="0">
                         <a:latin typeface="Calibri" charset="0"/>
@@ -3230,7 +3319,7 @@
                           <a:ea typeface="Calibri" pitchFamily="34" charset="-122"/>
                           <a:cs typeface="Calibri" pitchFamily="34" charset="-120"/>
                         </a:rPr>
-                        <a:t>Results table with PW by category, delta to lowest and closure days; charts for PW by category, expenditure stream, cumulative cost and rate sensitivity 2 to 8% with a 7% flag</a:t>
+                        <a:t>Formula-driven, no macro: results table with PW by category, delta to lowest, closure days and runway availability; five charts (category, rate sensitivity 2 to 8%, expenditure stream, cumulative cost, closure days); navigation buttons that work with macros blocked</a:t>
                       </a:r>
                       <a:endParaRPr lang="en-US" sz="1050" dirty="0">
                         <a:latin typeface="Calibri" charset="0"/>
@@ -3622,7 +3711,7 @@
                 <a:ea typeface="Calibri" pitchFamily="34" charset="-122"/>
                 <a:cs typeface="Calibri" pitchFamily="34" charset="-120"/>
               </a:rPr>
-              <a:t>Install: replace the Output module in the VBA editor with Output.bas. No other code changes.</a:t>
+              <a:t>Nothing to install: the workbook is self-contained. The VBA project is untouched; Alternative Setup still writes columns A:E of the Summary as before.</a:t>
             </a:r>
             <a:endParaRPr lang="en-US" sz="1250" dirty="0"/>
           </a:p>
@@ -3693,7 +3782,7 @@
                 <a:ea typeface="Cambria" pitchFamily="34" charset="-122"/>
                 <a:cs typeface="Cambria" pitchFamily="34" charset="-120"/>
               </a:rPr>
-              <a:t>The decision workbook</a:t>
+              <a:t>The new Summary sheet</a:t>
             </a:r>
             <a:endParaRPr lang="en-US" sz="2800" dirty="0"/>
           </a:p>
@@ -3732,7 +3821,7 @@
                 <a:ea typeface="Calibri" pitchFamily="34" charset="-122"/>
                 <a:cs typeface="Calibri" pitchFamily="34" charset="-120"/>
               </a:rPr>
-              <a:t>MBT and SRB already loaded, plus a blank TEMPLATE sheet. Yellow cells drive every table and chart.</a:t>
+              <a:t>MBT data loaded. Table, verdict line, five charts and the original comparison chart, all live formulas.</a:t>
             </a:r>
             <a:endParaRPr lang="en-US" sz="1300" dirty="0"/>
           </a:p>
@@ -3740,7 +3829,7 @@
       </p:sp>
       <p:pic>
         <p:nvPicPr>
-          <p:cNvPr id="4" name="Image 0" descr="/tmp/claude-0/-home-user-lcca-dashboard/444ca227-15d7-51d4-a51e-a0ae3dbe81ed/scratchpad/deck/img/MBT_kpis.png">    </p:cNvPr>
+          <p:cNvPr id="4" name="Image 0" descr="/tmp/claude-0/-home-user-lcca-dashboard/444ca227-15d7-51d4-a51e-a0ae3dbe81ed/scratchpad/deck/img/summary_sheet.png">    </p:cNvPr>
           <p:cNvPicPr>
             <a:picLocks noChangeAspect="1"/>
           </p:cNvPicPr>
@@ -3754,8 +3843,8 @@
         </p:blipFill>
         <p:spPr>
           <a:xfrm>
-            <a:off x="457200" y="1371600"/>
-            <a:ext cx="8229600" cy="2072947"/>
+            <a:off x="1143000" y="1234440"/>
+            <a:ext cx="6858000" cy="3345366"/>
           </a:xfrm>
           <a:prstGeom prst="rect">
             <a:avLst/>
@@ -3770,7 +3859,7 @@
         </p:nvSpPr>
         <p:spPr>
           <a:xfrm>
-            <a:off x="457200" y="3535987"/>
+            <a:off x="457200" y="4625526"/>
             <a:ext cx="8229600" cy="411480"/>
           </a:xfrm>
           <a:prstGeom prst="rect">
@@ -3795,115 +3884,9 @@
                 <a:ea typeface="Calibri" pitchFamily="34" charset="-122"/>
                 <a:cs typeface="Calibri" pitchFamily="34" charset="-120"/>
               </a:rPr>
-              <a:t>The verdict line: which alternative is lower, by how much, and two robustness flags a reviewer can read in five seconds. Shown here for MBT at TDOT settings.</a:t>
+              <a:t>Buttons at top left return to General Information and Instructions; a "View Summary" button sits under Alternative Setup. Chart data lives in columns W onward, marked "do not edit".</a:t>
             </a:r>
             <a:endParaRPr lang="en-US" sz="1050" dirty="0"/>
-          </a:p>
-        </p:txBody>
-      </p:sp>
-      <p:sp>
-        <p:nvSpPr>
-          <p:cNvPr id="6" name="Text 3"/>
-          <p:cNvSpPr txBox="1"/>
-          <p:nvPr/>
-        </p:nvSpPr>
-        <p:spPr>
-          <a:xfrm>
-            <a:off x="457200" y="3931920"/>
-            <a:ext cx="8229600" cy="914400"/>
-          </a:xfrm>
-          <a:prstGeom prst="rect">
-            <a:avLst/>
-          </a:prstGeom>
-          <a:noFill/>
-          <a:ln/>
-        </p:spPr>
-        <p:txBody>
-          <a:bodyPr wrap="square" lIns="0" tIns="0" rIns="0" bIns="0" rtlCol="0" anchor="t"/>
-          <a:lstStyle/>
-          <a:p>
-            <a:pPr marL="342900" indent="-342900">
-              <a:spcAft>
-                <a:spcPts val="500"/>
-              </a:spcAft>
-              <a:buSzPct val="100000"/>
-              <a:buChar char="•"/>
-            </a:pPr>
-            <a:r>
-              <a:rPr lang="en-US" sz="1150" dirty="0">
-                <a:solidFill>
-                  <a:srgbClr val="1F1F1F"/>
-                </a:solidFill>
-                <a:latin typeface="Calibri" pitchFamily="34" charset="0"/>
-                <a:ea typeface="Calibri" pitchFamily="34" charset="-122"/>
-                <a:cs typeface="Calibri" pitchFamily="34" charset="-120"/>
-              </a:rPr>
-              <a:t>RESULTS: present worth by category, EUAC, cost per SY, closure days, runway availability</a:t>
-            </a:r>
-            <a:endParaRPr lang="en-US" sz="1150" dirty="0"/>
-          </a:p>
-          <a:p>
-            <a:pPr marL="342900" indent="-342900">
-              <a:spcAft>
-                <a:spcPts val="500"/>
-              </a:spcAft>
-              <a:buSzPct val="100000"/>
-              <a:buChar char="•"/>
-            </a:pPr>
-            <a:r>
-              <a:rPr lang="en-US" sz="1150" dirty="0">
-                <a:solidFill>
-                  <a:srgbClr val="1F1F1F"/>
-                </a:solidFill>
-                <a:latin typeface="Calibri" pitchFamily="34" charset="0"/>
-                <a:ea typeface="Calibri" pitchFamily="34" charset="-122"/>
-                <a:cs typeface="Calibri" pitchFamily="34" charset="-120"/>
-              </a:rPr>
-              <a:t>BREAK-EVEN VALUES: the daily revenue, bid level, salvage fraction and discount rate at which the two tie</a:t>
-            </a:r>
-            <a:endParaRPr lang="en-US" sz="1150" dirty="0"/>
-          </a:p>
-          <a:p>
-            <a:pPr marL="342900" indent="-342900">
-              <a:spcAft>
-                <a:spcPts val="500"/>
-              </a:spcAft>
-              <a:buSzPct val="100000"/>
-              <a:buChar char="•"/>
-            </a:pPr>
-            <a:r>
-              <a:rPr lang="en-US" sz="1150" dirty="0">
-                <a:solidFill>
-                  <a:srgbClr val="1F1F1F"/>
-                </a:solidFill>
-                <a:latin typeface="Calibri" pitchFamily="34" charset="0"/>
-                <a:ea typeface="Calibri" pitchFamily="34" charset="-122"/>
-                <a:cs typeface="Calibri" pitchFamily="34" charset="-120"/>
-              </a:rPr>
-              <a:t>Twelve pre-run scenarios, a rate-by-salvage decision map, a tornado, and a live 1,000-draw simulation</a:t>
-            </a:r>
-            <a:endParaRPr lang="en-US" sz="1150" dirty="0"/>
-          </a:p>
-          <a:p>
-            <a:pPr marL="342900" indent="-342900">
-              <a:spcAft>
-                <a:spcPts val="500"/>
-              </a:spcAft>
-              <a:buSzPct val="100000"/>
-              <a:buChar char="•"/>
-            </a:pPr>
-            <a:r>
-              <a:rPr lang="en-US" sz="1150" dirty="0">
-                <a:solidFill>
-                  <a:srgbClr val="1F1F1F"/>
-                </a:solidFill>
-                <a:latin typeface="Calibri" pitchFamily="34" charset="0"/>
-                <a:ea typeface="Calibri" pitchFamily="34" charset="-122"/>
-                <a:cs typeface="Calibri" pitchFamily="34" charset="-120"/>
-              </a:rPr>
-              <a:t>A TEMPLATE sheet: copy it, paste the next project's costs and closure days, done</a:t>
-            </a:r>
-            <a:endParaRPr lang="en-US" sz="1150" dirty="0"/>
           </a:p>
         </p:txBody>
       </p:sp>
@@ -3972,15 +3955,54 @@
                 <a:ea typeface="Cambria" pitchFamily="34" charset="-122"/>
                 <a:cs typeface="Cambria" pitchFamily="34" charset="-120"/>
               </a:rPr>
-              <a:t>Where the difference comes from</a:t>
+              <a:t>The decision workbook</a:t>
             </a:r>
             <a:endParaRPr lang="en-US" sz="2800" dirty="0"/>
+          </a:p>
+        </p:txBody>
+      </p:sp>
+      <p:sp>
+        <p:nvSpPr>
+          <p:cNvPr id="3" name="Text 1"/>
+          <p:cNvSpPr txBox="1"/>
+          <p:nvPr/>
+        </p:nvSpPr>
+        <p:spPr>
+          <a:xfrm>
+            <a:off x="457200" y="914400"/>
+            <a:ext cx="8229600" cy="365760"/>
+          </a:xfrm>
+          <a:prstGeom prst="rect">
+            <a:avLst/>
+          </a:prstGeom>
+          <a:noFill/>
+          <a:ln/>
+        </p:spPr>
+        <p:txBody>
+          <a:bodyPr wrap="square" lIns="0" tIns="0" rIns="0" bIns="0" rtlCol="0" anchor="ctr"/>
+          <a:lstStyle/>
+          <a:p>
+            <a:pPr indent="0" marL="0">
+              <a:buNone/>
+            </a:pPr>
+            <a:r>
+              <a:rPr lang="en-US" sz="1300" i="1" dirty="0">
+                <a:solidFill>
+                  <a:srgbClr val="5F5F5F"/>
+                </a:solidFill>
+                <a:latin typeface="Calibri" pitchFamily="34" charset="0"/>
+                <a:ea typeface="Calibri" pitchFamily="34" charset="-122"/>
+                <a:cs typeface="Calibri" pitchFamily="34" charset="-120"/>
+              </a:rPr>
+              <a:t>MBT and SRB already loaded, plus a blank TEMPLATE sheet. Yellow cells drive every table and chart.</a:t>
+            </a:r>
+            <a:endParaRPr lang="en-US" sz="1300" dirty="0"/>
           </a:p>
         </p:txBody>
       </p:sp>
       <p:pic>
         <p:nvPicPr>
-          <p:cNvPr id="3" name="Image 0" descr="/tmp/claude-0/-home-user-lcca-dashboard/444ca227-15d7-51d4-a51e-a0ae3dbe81ed/scratchpad/deck/img/MBT_bridge.png">    </p:cNvPr>
+          <p:cNvPr id="4" name="Image 0" descr="/tmp/claude-0/-home-user-lcca-dashboard/444ca227-15d7-51d4-a51e-a0ae3dbe81ed/scratchpad/deck/img/MBT_kpis.png">    </p:cNvPr>
           <p:cNvPicPr>
             <a:picLocks noChangeAspect="1"/>
           </p:cNvPicPr>
@@ -3994,8 +4016,8 @@
         </p:blipFill>
         <p:spPr>
           <a:xfrm>
-            <a:off x="457200" y="1097280"/>
-            <a:ext cx="8229600" cy="1987826"/>
+            <a:off x="457200" y="1371600"/>
+            <a:ext cx="8229600" cy="2072947"/>
           </a:xfrm>
           <a:prstGeom prst="rect">
             <a:avLst/>
@@ -4004,13 +4026,13 @@
       </p:pic>
       <p:sp>
         <p:nvSpPr>
-          <p:cNvPr id="4" name="Text 1"/>
+          <p:cNvPr id="5" name="Text 2"/>
           <p:cNvSpPr txBox="1"/>
           <p:nvPr/>
         </p:nvSpPr>
         <p:spPr>
           <a:xfrm>
-            <a:off x="457200" y="3130826"/>
+            <a:off x="457200" y="3535987"/>
             <a:ext cx="8229600" cy="411480"/>
           </a:xfrm>
           <a:prstGeom prst="rect">
@@ -4035,46 +4057,22 @@
                 <a:ea typeface="Calibri" pitchFamily="34" charset="-122"/>
                 <a:cs typeface="Calibri" pitchFamily="34" charset="-120"/>
               </a:rPr>
-              <a:t>MBT bridge from HMA to PCC present worth. PCC costs $3.1M more to build and earns it back through $1.9M less maintenance and $1.1M less rehabilitation; salvage and lost revenue are small here.</a:t>
+              <a:t>The verdict line: which alternative is lower, by how much, and two robustness flags a reviewer can read in five seconds. Shown here for MBT at TDOT settings.</a:t>
             </a:r>
             <a:endParaRPr lang="en-US" sz="1050" dirty="0"/>
           </a:p>
         </p:txBody>
       </p:sp>
-      <p:pic>
-        <p:nvPicPr>
-          <p:cNvPr id="5" name="Image 1" descr="/tmp/claude-0/-home-user-lcca-dashboard/444ca227-15d7-51d4-a51e-a0ae3dbe81ed/scratchpad/deck/img/MBT_closures.png">    </p:cNvPr>
-          <p:cNvPicPr>
-            <a:picLocks noChangeAspect="1"/>
-          </p:cNvPicPr>
-          <p:nvPr/>
-        </p:nvPicPr>
-        <p:blipFill>
-          <a:blip r:embed="rId2"/>
-          <a:stretch>
-            <a:fillRect/>
-          </a:stretch>
-        </p:blipFill>
-        <p:spPr>
-          <a:xfrm>
-            <a:off x="457200" y="3588026"/>
-            <a:ext cx="8229600" cy="1277888"/>
-          </a:xfrm>
-          <a:prstGeom prst="rect">
-            <a:avLst/>
-          </a:prstGeom>
-        </p:spPr>
-      </p:pic>
       <p:sp>
         <p:nvSpPr>
-          <p:cNvPr id="6" name="Text 2"/>
+          <p:cNvPr id="6" name="Text 3"/>
           <p:cNvSpPr txBox="1"/>
           <p:nvPr/>
         </p:nvSpPr>
         <p:spPr>
           <a:xfrm>
-            <a:off x="457200" y="4911634"/>
-            <a:ext cx="8229600" cy="411480"/>
+            <a:off x="457200" y="3931920"/>
+            <a:ext cx="8229600" cy="914400"/>
           </a:xfrm>
           <a:prstGeom prst="rect">
             <a:avLst/>
@@ -4086,21 +4084,88 @@
           <a:bodyPr wrap="square" lIns="0" tIns="0" rIns="0" bIns="0" rtlCol="0" anchor="t"/>
           <a:lstStyle/>
           <a:p>
-            <a:pPr indent="0" marL="0">
-              <a:buNone/>
+            <a:pPr marL="342900" indent="-342900">
+              <a:spcAft>
+                <a:spcPts val="500"/>
+              </a:spcAft>
+              <a:buSzPct val="100000"/>
+              <a:buChar char="•"/>
             </a:pPr>
             <a:r>
-              <a:rPr lang="en-US" sz="1050" dirty="0">
+              <a:rPr lang="en-US" sz="1150" dirty="0">
                 <a:solidFill>
-                  <a:srgbClr val="5F5F5F"/>
+                  <a:srgbClr val="1F1F1F"/>
                 </a:solidFill>
                 <a:latin typeface="Calibri" pitchFamily="34" charset="0"/>
                 <a:ea typeface="Calibri" pitchFamily="34" charset="-122"/>
                 <a:cs typeface="Calibri" pitchFamily="34" charset="-120"/>
               </a:rPr>
-              <a:t>Closure timeline, bubble size is days closed. HMA closes the runway seven times for 57 days; PCC twice for 27 days.</a:t>
+              <a:t>RESULTS: present worth by category, EUAC, cost per SY, closure days, runway availability</a:t>
             </a:r>
-            <a:endParaRPr lang="en-US" sz="1050" dirty="0"/>
+            <a:endParaRPr lang="en-US" sz="1150" dirty="0"/>
+          </a:p>
+          <a:p>
+            <a:pPr marL="342900" indent="-342900">
+              <a:spcAft>
+                <a:spcPts val="500"/>
+              </a:spcAft>
+              <a:buSzPct val="100000"/>
+              <a:buChar char="•"/>
+            </a:pPr>
+            <a:r>
+              <a:rPr lang="en-US" sz="1150" dirty="0">
+                <a:solidFill>
+                  <a:srgbClr val="1F1F1F"/>
+                </a:solidFill>
+                <a:latin typeface="Calibri" pitchFamily="34" charset="0"/>
+                <a:ea typeface="Calibri" pitchFamily="34" charset="-122"/>
+                <a:cs typeface="Calibri" pitchFamily="34" charset="-120"/>
+              </a:rPr>
+              <a:t>BREAK-EVEN VALUES: the daily revenue, bid level, salvage fraction and discount rate at which the two tie</a:t>
+            </a:r>
+            <a:endParaRPr lang="en-US" sz="1150" dirty="0"/>
+          </a:p>
+          <a:p>
+            <a:pPr marL="342900" indent="-342900">
+              <a:spcAft>
+                <a:spcPts val="500"/>
+              </a:spcAft>
+              <a:buSzPct val="100000"/>
+              <a:buChar char="•"/>
+            </a:pPr>
+            <a:r>
+              <a:rPr lang="en-US" sz="1150" dirty="0">
+                <a:solidFill>
+                  <a:srgbClr val="1F1F1F"/>
+                </a:solidFill>
+                <a:latin typeface="Calibri" pitchFamily="34" charset="0"/>
+                <a:ea typeface="Calibri" pitchFamily="34" charset="-122"/>
+                <a:cs typeface="Calibri" pitchFamily="34" charset="-120"/>
+              </a:rPr>
+              <a:t>Twelve pre-run scenarios, a rate-by-salvage decision map, a tornado, and a live 1,000-draw simulation</a:t>
+            </a:r>
+            <a:endParaRPr lang="en-US" sz="1150" dirty="0"/>
+          </a:p>
+          <a:p>
+            <a:pPr marL="342900" indent="-342900">
+              <a:spcAft>
+                <a:spcPts val="500"/>
+              </a:spcAft>
+              <a:buSzPct val="100000"/>
+              <a:buChar char="•"/>
+            </a:pPr>
+            <a:r>
+              <a:rPr lang="en-US" sz="1150" dirty="0">
+                <a:solidFill>
+                  <a:srgbClr val="1F1F1F"/>
+                </a:solidFill>
+                <a:latin typeface="Calibri" pitchFamily="34" charset="0"/>
+                <a:ea typeface="Calibri" pitchFamily="34" charset="-122"/>
+                <a:cs typeface="Calibri" pitchFamily="34" charset="-120"/>
+              </a:rPr>
+              <a:t>A TEMPLATE sheet: copy it, paste the next project's costs and closure days, done</a:t>
+            </a:r>
+            <a:endParaRPr lang="en-US" sz="1150" dirty="0"/>
           </a:p>
         </p:txBody>
       </p:sp>
@@ -4169,54 +4234,15 @@
                 <a:ea typeface="Cambria" pitchFamily="34" charset="-122"/>
                 <a:cs typeface="Cambria" pitchFamily="34" charset="-120"/>
               </a:rPr>
-              <a:t>Will the answer hold?</a:t>
+              <a:t>Where the difference comes from</a:t>
             </a:r>
             <a:endParaRPr lang="en-US" sz="2800" dirty="0"/>
-          </a:p>
-        </p:txBody>
-      </p:sp>
-      <p:sp>
-        <p:nvSpPr>
-          <p:cNvPr id="3" name="Text 1"/>
-          <p:cNvSpPr txBox="1"/>
-          <p:nvPr/>
-        </p:nvSpPr>
-        <p:spPr>
-          <a:xfrm>
-            <a:off x="457200" y="914400"/>
-            <a:ext cx="8229600" cy="365760"/>
-          </a:xfrm>
-          <a:prstGeom prst="rect">
-            <a:avLst/>
-          </a:prstGeom>
-          <a:noFill/>
-          <a:ln/>
-        </p:spPr>
-        <p:txBody>
-          <a:bodyPr wrap="square" lIns="0" tIns="0" rIns="0" bIns="0" rtlCol="0" anchor="ctr"/>
-          <a:lstStyle/>
-          <a:p>
-            <a:pPr indent="0" marL="0">
-              <a:buNone/>
-            </a:pPr>
-            <a:r>
-              <a:rPr lang="en-US" sz="1300" i="1" dirty="0">
-                <a:solidFill>
-                  <a:srgbClr val="5F5F5F"/>
-                </a:solidFill>
-                <a:latin typeface="Calibri" pitchFamily="34" charset="0"/>
-                <a:ea typeface="Calibri" pitchFamily="34" charset="-122"/>
-                <a:cs typeface="Calibri" pitchFamily="34" charset="-120"/>
-              </a:rPr>
-              <a:t>Net present worth against discount rate. Blue is HMA, orange is PCC. TDOT 3 percent and FAA AIP 7 percent are marked.</a:t>
-            </a:r>
-            <a:endParaRPr lang="en-US" sz="1300" dirty="0"/>
           </a:p>
         </p:txBody>
       </p:sp>
       <p:pic>
         <p:nvPicPr>
-          <p:cNvPr id="4" name="Image 0" descr="/tmp/claude-0/-home-user-lcca-dashboard/444ca227-15d7-51d4-a51e-a0ae3dbe81ed/scratchpad/deck/img/MBT_sens.png">    </p:cNvPr>
+          <p:cNvPr id="3" name="Image 0" descr="/tmp/claude-0/-home-user-lcca-dashboard/444ca227-15d7-51d4-a51e-a0ae3dbe81ed/scratchpad/deck/img/MBT_bridge.png">    </p:cNvPr>
           <p:cNvPicPr>
             <a:picLocks noChangeAspect="1"/>
           </p:cNvPicPr>
@@ -4230,8 +4256,8 @@
         </p:blipFill>
         <p:spPr>
           <a:xfrm>
-            <a:off x="457200" y="1371600"/>
-            <a:ext cx="3931920" cy="1899478"/>
+            <a:off x="457200" y="1097280"/>
+            <a:ext cx="8229600" cy="1987826"/>
           </a:xfrm>
           <a:prstGeom prst="rect">
             <a:avLst/>
@@ -4240,14 +4266,14 @@
       </p:pic>
       <p:sp>
         <p:nvSpPr>
-          <p:cNvPr id="5" name="Text 2"/>
+          <p:cNvPr id="4" name="Text 1"/>
           <p:cNvSpPr txBox="1"/>
           <p:nvPr/>
         </p:nvSpPr>
         <p:spPr>
           <a:xfrm>
-            <a:off x="457200" y="3316798"/>
-            <a:ext cx="3931920" cy="411480"/>
+            <a:off x="457200" y="3130826"/>
+            <a:ext cx="8229600" cy="411480"/>
           </a:xfrm>
           <a:prstGeom prst="rect">
             <a:avLst/>
@@ -4271,7 +4297,7 @@
                 <a:ea typeface="Calibri" pitchFamily="34" charset="-122"/>
                 <a:cs typeface="Calibri" pitchFamily="34" charset="-120"/>
               </a:rPr>
-              <a:t>MBT: PCC wins below 4.5 percent, HMA above. At the FAA AIP rate the answer reverses.</a:t>
+              <a:t>MBT bridge from HMA to PCC present worth. PCC costs $3.1M more to build and earns it back through $1.9M less maintenance and $1.1M less rehabilitation; salvage and lost revenue are small here.</a:t>
             </a:r>
             <a:endParaRPr lang="en-US" sz="1050" dirty="0"/>
           </a:p>
@@ -4279,7 +4305,7 @@
       </p:sp>
       <p:pic>
         <p:nvPicPr>
-          <p:cNvPr id="6" name="Image 1" descr="/tmp/claude-0/-home-user-lcca-dashboard/444ca227-15d7-51d4-a51e-a0ae3dbe81ed/scratchpad/deck/img/SRB_sens.png">    </p:cNvPr>
+          <p:cNvPr id="5" name="Image 1" descr="/tmp/claude-0/-home-user-lcca-dashboard/444ca227-15d7-51d4-a51e-a0ae3dbe81ed/scratchpad/deck/img/MBT_closures.png">    </p:cNvPr>
           <p:cNvPicPr>
             <a:picLocks noChangeAspect="1"/>
           </p:cNvPicPr>
@@ -4293,8 +4319,8 @@
         </p:blipFill>
         <p:spPr>
           <a:xfrm>
-            <a:off x="4754880" y="1371600"/>
-            <a:ext cx="3931920" cy="1899478"/>
+            <a:off x="457200" y="3588026"/>
+            <a:ext cx="8229600" cy="1277888"/>
           </a:xfrm>
           <a:prstGeom prst="rect">
             <a:avLst/>
@@ -4303,14 +4329,14 @@
       </p:pic>
       <p:sp>
         <p:nvSpPr>
-          <p:cNvPr id="7" name="Text 3"/>
+          <p:cNvPr id="6" name="Text 2"/>
           <p:cNvSpPr txBox="1"/>
           <p:nvPr/>
         </p:nvSpPr>
         <p:spPr>
           <a:xfrm>
-            <a:off x="4754880" y="3316798"/>
-            <a:ext cx="3931920" cy="411480"/>
+            <a:off x="457200" y="4911634"/>
+            <a:ext cx="8229600" cy="411480"/>
           </a:xfrm>
           <a:prstGeom prst="rect">
             <a:avLst/>
@@ -4334,89 +4360,9 @@
                 <a:ea typeface="Calibri" pitchFamily="34" charset="-122"/>
                 <a:cs typeface="Calibri" pitchFamily="34" charset="-120"/>
               </a:rPr>
-              <a:t>SRB: HMA wins at every rate above 2.5 percent. The gap widens as the rate rises.</a:t>
+              <a:t>Closure timeline, bubble size is days closed. HMA closes the runway seven times for 57 days; PCC twice for 27 days.</a:t>
             </a:r>
             <a:endParaRPr lang="en-US" sz="1050" dirty="0"/>
-          </a:p>
-        </p:txBody>
-      </p:sp>
-      <p:sp>
-        <p:nvSpPr>
-          <p:cNvPr id="8" name="Shape 4"/>
-          <p:cNvSpPr/>
-          <p:nvPr/>
-        </p:nvSpPr>
-        <p:spPr>
-          <a:xfrm>
-            <a:off x="457200" y="3794760"/>
-            <a:ext cx="8229600" cy="777240"/>
-          </a:xfrm>
-          <a:prstGeom prst="roundRect">
-            <a:avLst>
-              <a:gd name="adj" fmla="val 7059"/>
-            </a:avLst>
-          </a:prstGeom>
-          <a:solidFill>
-            <a:srgbClr val="F3F3F1"/>
-          </a:solidFill>
-          <a:ln w="12700">
-            <a:solidFill>
-              <a:srgbClr val="F3F3F1"/>
-            </a:solidFill>
-            <a:prstDash val="solid"/>
-          </a:ln>
-        </p:spPr>
-      </p:sp>
-      <p:sp>
-        <p:nvSpPr>
-          <p:cNvPr id="9" name="Text 5"/>
-          <p:cNvSpPr txBox="1"/>
-          <p:nvPr/>
-        </p:nvSpPr>
-        <p:spPr>
-          <a:xfrm>
-            <a:off x="640080" y="3840480"/>
-            <a:ext cx="7863840" cy="685800"/>
-          </a:xfrm>
-          <a:prstGeom prst="rect">
-            <a:avLst/>
-          </a:prstGeom>
-          <a:noFill/>
-          <a:ln/>
-        </p:spPr>
-        <p:txBody>
-          <a:bodyPr wrap="square" lIns="0" tIns="0" rIns="0" bIns="0" rtlCol="0" anchor="ctr"/>
-          <a:lstStyle/>
-          <a:p>
-            <a:pPr indent="0" marL="0">
-              <a:buNone/>
-            </a:pPr>
-            <a:r>
-              <a:rPr lang="en-US" sz="1200" b="1" dirty="0">
-                <a:solidFill>
-                  <a:srgbClr val="1F1F1F"/>
-                </a:solidFill>
-                <a:latin typeface="Calibri" pitchFamily="34" charset="0"/>
-                <a:ea typeface="Calibri" pitchFamily="34" charset="-122"/>
-                <a:cs typeface="Calibri" pitchFamily="34" charset="-120"/>
-              </a:rPr>
-              <a:t>Live simulation: </a:t>
-            </a:r>
-            <a:pPr indent="0" marL="0">
-              <a:buNone/>
-            </a:pPr>
-            <a:r>
-              <a:rPr lang="en-US" sz="1200" dirty="0">
-                <a:solidFill>
-                  <a:srgbClr val="1F1F1F"/>
-                </a:solidFill>
-                <a:latin typeface="Calibri" pitchFamily="34" charset="0"/>
-                <a:ea typeface="Calibri" pitchFamily="34" charset="-122"/>
-                <a:cs typeface="Calibri" pitchFamily="34" charset="-120"/>
-              </a:rPr>
-              <a:t>1,000 joint draws on rate, bids, closures, salvage and revenue share. Probability PCC is the cheaper alternative: 52 percent at MBT, 18 percent at SRB. Press F9 in the workbook to redraw.</a:t>
-            </a:r>
-            <a:endParaRPr lang="en-US" sz="1200" dirty="0"/>
           </a:p>
         </p:txBody>
       </p:sp>
@@ -4485,6 +4431,322 @@
                 <a:ea typeface="Cambria" pitchFamily="34" charset="-122"/>
                 <a:cs typeface="Cambria" pitchFamily="34" charset="-120"/>
               </a:rPr>
+              <a:t>Will the answer hold?</a:t>
+            </a:r>
+            <a:endParaRPr lang="en-US" sz="2800" dirty="0"/>
+          </a:p>
+        </p:txBody>
+      </p:sp>
+      <p:sp>
+        <p:nvSpPr>
+          <p:cNvPr id="3" name="Text 1"/>
+          <p:cNvSpPr txBox="1"/>
+          <p:nvPr/>
+        </p:nvSpPr>
+        <p:spPr>
+          <a:xfrm>
+            <a:off x="457200" y="914400"/>
+            <a:ext cx="8229600" cy="365760"/>
+          </a:xfrm>
+          <a:prstGeom prst="rect">
+            <a:avLst/>
+          </a:prstGeom>
+          <a:noFill/>
+          <a:ln/>
+        </p:spPr>
+        <p:txBody>
+          <a:bodyPr wrap="square" lIns="0" tIns="0" rIns="0" bIns="0" rtlCol="0" anchor="ctr"/>
+          <a:lstStyle/>
+          <a:p>
+            <a:pPr indent="0" marL="0">
+              <a:buNone/>
+            </a:pPr>
+            <a:r>
+              <a:rPr lang="en-US" sz="1300" i="1" dirty="0">
+                <a:solidFill>
+                  <a:srgbClr val="5F5F5F"/>
+                </a:solidFill>
+                <a:latin typeface="Calibri" pitchFamily="34" charset="0"/>
+                <a:ea typeface="Calibri" pitchFamily="34" charset="-122"/>
+                <a:cs typeface="Calibri" pitchFamily="34" charset="-120"/>
+              </a:rPr>
+              <a:t>Net present worth against discount rate. Blue is HMA, orange is PCC. TDOT 3 percent and FAA AIP 7 percent are marked.</a:t>
+            </a:r>
+            <a:endParaRPr lang="en-US" sz="1300" dirty="0"/>
+          </a:p>
+        </p:txBody>
+      </p:sp>
+      <p:pic>
+        <p:nvPicPr>
+          <p:cNvPr id="4" name="Image 0" descr="/tmp/claude-0/-home-user-lcca-dashboard/444ca227-15d7-51d4-a51e-a0ae3dbe81ed/scratchpad/deck/img/MBT_sens.png">    </p:cNvPr>
+          <p:cNvPicPr>
+            <a:picLocks noChangeAspect="1"/>
+          </p:cNvPicPr>
+          <p:nvPr/>
+        </p:nvPicPr>
+        <p:blipFill>
+          <a:blip r:embed="rId1"/>
+          <a:stretch>
+            <a:fillRect/>
+          </a:stretch>
+        </p:blipFill>
+        <p:spPr>
+          <a:xfrm>
+            <a:off x="457200" y="1371600"/>
+            <a:ext cx="3931920" cy="1899478"/>
+          </a:xfrm>
+          <a:prstGeom prst="rect">
+            <a:avLst/>
+          </a:prstGeom>
+        </p:spPr>
+      </p:pic>
+      <p:sp>
+        <p:nvSpPr>
+          <p:cNvPr id="5" name="Text 2"/>
+          <p:cNvSpPr txBox="1"/>
+          <p:nvPr/>
+        </p:nvSpPr>
+        <p:spPr>
+          <a:xfrm>
+            <a:off x="457200" y="3316798"/>
+            <a:ext cx="3931920" cy="411480"/>
+          </a:xfrm>
+          <a:prstGeom prst="rect">
+            <a:avLst/>
+          </a:prstGeom>
+          <a:noFill/>
+          <a:ln/>
+        </p:spPr>
+        <p:txBody>
+          <a:bodyPr wrap="square" lIns="0" tIns="0" rIns="0" bIns="0" rtlCol="0" anchor="t"/>
+          <a:lstStyle/>
+          <a:p>
+            <a:pPr indent="0" marL="0">
+              <a:buNone/>
+            </a:pPr>
+            <a:r>
+              <a:rPr lang="en-US" sz="1050" dirty="0">
+                <a:solidFill>
+                  <a:srgbClr val="5F5F5F"/>
+                </a:solidFill>
+                <a:latin typeface="Calibri" pitchFamily="34" charset="0"/>
+                <a:ea typeface="Calibri" pitchFamily="34" charset="-122"/>
+                <a:cs typeface="Calibri" pitchFamily="34" charset="-120"/>
+              </a:rPr>
+              <a:t>MBT: PCC wins below 4.5 percent, HMA above. At the FAA AIP rate the answer reverses.</a:t>
+            </a:r>
+            <a:endParaRPr lang="en-US" sz="1050" dirty="0"/>
+          </a:p>
+        </p:txBody>
+      </p:sp>
+      <p:pic>
+        <p:nvPicPr>
+          <p:cNvPr id="6" name="Image 1" descr="/tmp/claude-0/-home-user-lcca-dashboard/444ca227-15d7-51d4-a51e-a0ae3dbe81ed/scratchpad/deck/img/SRB_sens.png">    </p:cNvPr>
+          <p:cNvPicPr>
+            <a:picLocks noChangeAspect="1"/>
+          </p:cNvPicPr>
+          <p:nvPr/>
+        </p:nvPicPr>
+        <p:blipFill>
+          <a:blip r:embed="rId2"/>
+          <a:stretch>
+            <a:fillRect/>
+          </a:stretch>
+        </p:blipFill>
+        <p:spPr>
+          <a:xfrm>
+            <a:off x="4754880" y="1371600"/>
+            <a:ext cx="3931920" cy="1899478"/>
+          </a:xfrm>
+          <a:prstGeom prst="rect">
+            <a:avLst/>
+          </a:prstGeom>
+        </p:spPr>
+      </p:pic>
+      <p:sp>
+        <p:nvSpPr>
+          <p:cNvPr id="7" name="Text 3"/>
+          <p:cNvSpPr txBox="1"/>
+          <p:nvPr/>
+        </p:nvSpPr>
+        <p:spPr>
+          <a:xfrm>
+            <a:off x="4754880" y="3316798"/>
+            <a:ext cx="3931920" cy="411480"/>
+          </a:xfrm>
+          <a:prstGeom prst="rect">
+            <a:avLst/>
+          </a:prstGeom>
+          <a:noFill/>
+          <a:ln/>
+        </p:spPr>
+        <p:txBody>
+          <a:bodyPr wrap="square" lIns="0" tIns="0" rIns="0" bIns="0" rtlCol="0" anchor="t"/>
+          <a:lstStyle/>
+          <a:p>
+            <a:pPr indent="0" marL="0">
+              <a:buNone/>
+            </a:pPr>
+            <a:r>
+              <a:rPr lang="en-US" sz="1050" dirty="0">
+                <a:solidFill>
+                  <a:srgbClr val="5F5F5F"/>
+                </a:solidFill>
+                <a:latin typeface="Calibri" pitchFamily="34" charset="0"/>
+                <a:ea typeface="Calibri" pitchFamily="34" charset="-122"/>
+                <a:cs typeface="Calibri" pitchFamily="34" charset="-120"/>
+              </a:rPr>
+              <a:t>SRB: HMA wins at every rate above 2.5 percent. The gap widens as the rate rises.</a:t>
+            </a:r>
+            <a:endParaRPr lang="en-US" sz="1050" dirty="0"/>
+          </a:p>
+        </p:txBody>
+      </p:sp>
+      <p:sp>
+        <p:nvSpPr>
+          <p:cNvPr id="8" name="Shape 4"/>
+          <p:cNvSpPr/>
+          <p:nvPr/>
+        </p:nvSpPr>
+        <p:spPr>
+          <a:xfrm>
+            <a:off x="457200" y="3794760"/>
+            <a:ext cx="8229600" cy="777240"/>
+          </a:xfrm>
+          <a:prstGeom prst="roundRect">
+            <a:avLst>
+              <a:gd name="adj" fmla="val 7059"/>
+            </a:avLst>
+          </a:prstGeom>
+          <a:solidFill>
+            <a:srgbClr val="F3F3F1"/>
+          </a:solidFill>
+          <a:ln w="12700">
+            <a:solidFill>
+              <a:srgbClr val="F3F3F1"/>
+            </a:solidFill>
+            <a:prstDash val="solid"/>
+          </a:ln>
+        </p:spPr>
+      </p:sp>
+      <p:sp>
+        <p:nvSpPr>
+          <p:cNvPr id="9" name="Text 5"/>
+          <p:cNvSpPr txBox="1"/>
+          <p:nvPr/>
+        </p:nvSpPr>
+        <p:spPr>
+          <a:xfrm>
+            <a:off x="640080" y="3840480"/>
+            <a:ext cx="7863840" cy="685800"/>
+          </a:xfrm>
+          <a:prstGeom prst="rect">
+            <a:avLst/>
+          </a:prstGeom>
+          <a:noFill/>
+          <a:ln/>
+        </p:spPr>
+        <p:txBody>
+          <a:bodyPr wrap="square" lIns="0" tIns="0" rIns="0" bIns="0" rtlCol="0" anchor="ctr"/>
+          <a:lstStyle/>
+          <a:p>
+            <a:pPr indent="0" marL="0">
+              <a:buNone/>
+            </a:pPr>
+            <a:r>
+              <a:rPr lang="en-US" sz="1200" b="1" dirty="0">
+                <a:solidFill>
+                  <a:srgbClr val="1F1F1F"/>
+                </a:solidFill>
+                <a:latin typeface="Calibri" pitchFamily="34" charset="0"/>
+                <a:ea typeface="Calibri" pitchFamily="34" charset="-122"/>
+                <a:cs typeface="Calibri" pitchFamily="34" charset="-120"/>
+              </a:rPr>
+              <a:t>Live simulation: </a:t>
+            </a:r>
+            <a:pPr indent="0" marL="0">
+              <a:buNone/>
+            </a:pPr>
+            <a:r>
+              <a:rPr lang="en-US" sz="1200" dirty="0">
+                <a:solidFill>
+                  <a:srgbClr val="1F1F1F"/>
+                </a:solidFill>
+                <a:latin typeface="Calibri" pitchFamily="34" charset="0"/>
+                <a:ea typeface="Calibri" pitchFamily="34" charset="-122"/>
+                <a:cs typeface="Calibri" pitchFamily="34" charset="-120"/>
+              </a:rPr>
+              <a:t>1,000 joint draws on rate, bids, closures, salvage and revenue share. Probability PCC is the cheaper alternative: 52 percent at MBT, 18 percent at SRB. Press F9 in the workbook to redraw.</a:t>
+            </a:r>
+            <a:endParaRPr lang="en-US" sz="1200" dirty="0"/>
+          </a:p>
+        </p:txBody>
+      </p:sp>
+    </p:spTree>
+  </p:cSld>
+  <p:clrMapOvr>
+    <a:masterClrMapping/>
+  </p:clrMapOvr>
+</p:sld>
+</file>
+
+<file path=ppt/slides/slide15.xml><?xml version="1.0" encoding="utf-8"?>
+<p:sld xmlns:a="http://schemas.openxmlformats.org/drawingml/2006/main" xmlns:r="http://schemas.openxmlformats.org/officeDocument/2006/relationships" xmlns:p="http://schemas.openxmlformats.org/presentationml/2006/main">
+  <p:cSld name="Slide 15">
+    <p:bg>
+      <p:bgPr>
+        <a:solidFill>
+          <a:srgbClr val="FFFFFF"/>
+        </a:solidFill>
+      </p:bgPr>
+    </p:bg>
+    <p:spTree>
+      <p:nvGrpSpPr>
+        <p:cNvPr id="1" name=""/>
+        <p:cNvGrpSpPr/>
+        <p:nvPr/>
+      </p:nvGrpSpPr>
+      <p:grpSpPr>
+        <a:xfrm>
+          <a:off x="0" y="0"/>
+          <a:ext cx="0" cy="0"/>
+          <a:chOff x="0" y="0"/>
+          <a:chExt cx="0" cy="0"/>
+        </a:xfrm>
+      </p:grpSpPr>
+      <p:sp>
+        <p:nvSpPr>
+          <p:cNvPr id="2" name="Text 0"/>
+          <p:cNvSpPr txBox="1"/>
+          <p:nvPr/>
+        </p:nvSpPr>
+        <p:spPr>
+          <a:xfrm>
+            <a:off x="457200" y="320040"/>
+            <a:ext cx="8229600" cy="640080"/>
+          </a:xfrm>
+          <a:prstGeom prst="rect">
+            <a:avLst/>
+          </a:prstGeom>
+          <a:noFill/>
+          <a:ln/>
+        </p:spPr>
+        <p:txBody>
+          <a:bodyPr wrap="square" lIns="0" tIns="0" rIns="0" bIns="0" rtlCol="0" anchor="t"/>
+          <a:lstStyle/>
+          <a:p>
+            <a:pPr indent="0" marL="0">
+              <a:buNone/>
+            </a:pPr>
+            <a:r>
+              <a:rPr lang="en-US" sz="2800" b="1" dirty="0">
+                <a:solidFill>
+                  <a:srgbClr val="1F1F1F"/>
+                </a:solidFill>
+                <a:latin typeface="Cambria" pitchFamily="34" charset="0"/>
+                <a:ea typeface="Cambria" pitchFamily="34" charset="-122"/>
+                <a:cs typeface="Cambria" pitchFamily="34" charset="-120"/>
+              </a:rPr>
               <a:t>What could flip the answer</a:t>
             </a:r>
             <a:endParaRPr lang="en-US" sz="2800" dirty="0"/>
@@ -4595,7 +4857,7 @@
       </p:sp>
       <p:graphicFrame>
         <p:nvGraphicFramePr>
-          <p:cNvPr id="15" name="Table 0"/>
+          <p:cNvPr id="16" name="Table 0"/>
           <p:cNvGraphicFramePr>
             <a:graphicFrameLocks noGrp="1"/>
           </p:cNvGraphicFramePr>
@@ -5456,9 +5718,9 @@
 </p:sld>
 </file>
 
-<file path=ppt/slides/slide15.xml><?xml version="1.0" encoding="utf-8"?>
+<file path=ppt/slides/slide16.xml><?xml version="1.0" encoding="utf-8"?>
 <p:sld xmlns:a="http://schemas.openxmlformats.org/drawingml/2006/main" xmlns:r="http://schemas.openxmlformats.org/officeDocument/2006/relationships" xmlns:p="http://schemas.openxmlformats.org/presentationml/2006/main">
-  <p:cSld name="Slide 15">
+  <p:cSld name="Slide 16">
     <p:bg>
       <p:bgPr>
         <a:solidFill>
@@ -5560,7 +5822,7 @@
       </p:sp>
       <p:graphicFrame>
         <p:nvGraphicFramePr>
-          <p:cNvPr id="16" name="Table 0"/>
+          <p:cNvPr id="17" name="Table 0"/>
           <p:cNvGraphicFramePr>
             <a:graphicFrameLocks noGrp="1"/>
           </p:cNvGraphicFramePr>
@@ -7160,9 +7422,9 @@
 </p:sld>
 </file>
 
-<file path=ppt/slides/slide16.xml><?xml version="1.0" encoding="utf-8"?>
+<file path=ppt/slides/slide17.xml><?xml version="1.0" encoding="utf-8"?>
 <p:sld xmlns:a="http://schemas.openxmlformats.org/drawingml/2006/main" xmlns:r="http://schemas.openxmlformats.org/officeDocument/2006/relationships" xmlns:p="http://schemas.openxmlformats.org/presentationml/2006/main">
-  <p:cSld name="Slide 16">
+  <p:cSld name="Slide 17">
     <p:bg>
       <p:bgPr>
         <a:solidFill>
@@ -7225,7 +7487,7 @@
       </p:sp>
       <p:graphicFrame>
         <p:nvGraphicFramePr>
-          <p:cNvPr id="17" name="Table 0"/>
+          <p:cNvPr id="18" name="Table 0"/>
           <p:cNvGraphicFramePr>
             <a:graphicFrameLocks noGrp="1"/>
           </p:cNvGraphicFramePr>
@@ -7473,7 +7735,7 @@
                           <a:ea typeface="Calibri" pitchFamily="34" charset="-122"/>
                           <a:cs typeface="Calibri" pitchFamily="34" charset="-120"/>
                         </a:rPr>
-                        <a:t>1,644 formulas, 0 errors (v1.1.2 shows 99 error cells under the same recalc)</a:t>
+                        <a:t>2,240 formulas incl. the new Summary, 0 errors (v1.1.2 shows 99 error cells under the same recalc)</a:t>
                       </a:r>
                       <a:endParaRPr lang="en-US" sz="1050" dirty="0">
                         <a:latin typeface="Calibri" charset="0"/>
@@ -8371,7 +8633,7 @@
                           <a:ea typeface="Calibri" pitchFamily="34" charset="-122"/>
                           <a:cs typeface="Calibri" pitchFamily="34" charset="-120"/>
                         </a:rPr>
-                        <a:t>Not yet verified</a:t>
+                        <a:t>New Summary sheet on the MBT data</a:t>
                       </a:r>
                       <a:endParaRPr lang="en-US" sz="1050" dirty="0">
                         <a:latin typeface="Calibri" charset="0"/>
@@ -8439,7 +8701,145 @@
                           <a:ea typeface="Calibri" pitchFamily="34" charset="-122"/>
                           <a:cs typeface="Calibri" pitchFamily="34" charset="-120"/>
                         </a:rPr>
-                        <a:t>Output.bas in Excel (no Excel here) and the patched charts in Excel itself; a six-step first-open check is in the notes</a:t>
+                        <a:t>Table, verdict, categories and closure days match; six charts render; template reads "No alternatives yet" with no errors</a:t>
+                      </a:r>
+                      <a:endParaRPr lang="en-US" sz="1050" dirty="0">
+                        <a:latin typeface="Calibri" charset="0"/>
+                        <a:ea typeface="Calibri" charset="0"/>
+                        <a:cs typeface="Calibri" charset="0"/>
+                      </a:endParaRPr>
+                    </a:p>
+                  </a:txBody>
+                  <a:tcPr marL="45720" marR="45720" marT="45720" marB="45720" anchor="ctr">
+                    <a:lnL w="6350" cap="flat" cmpd="sng" algn="ctr">
+                      <a:solidFill>
+                        <a:srgbClr val="C9C9C4"/>
+                      </a:solidFill>
+                      <a:prstDash val="solid"/>
+                      <a:round/>
+                      <a:headEnd type="none" w="med" len="med"/>
+                      <a:tailEnd type="none" w="med" len="med"/>
+                    </a:lnL>
+                    <a:lnR w="6350" cap="flat" cmpd="sng" algn="ctr">
+                      <a:solidFill>
+                        <a:srgbClr val="C9C9C4"/>
+                      </a:solidFill>
+                      <a:prstDash val="solid"/>
+                      <a:round/>
+                      <a:headEnd type="none" w="med" len="med"/>
+                      <a:tailEnd type="none" w="med" len="med"/>
+                    </a:lnR>
+                    <a:lnT w="6350" cap="flat" cmpd="sng" algn="ctr">
+                      <a:solidFill>
+                        <a:srgbClr val="C9C9C4"/>
+                      </a:solidFill>
+                      <a:prstDash val="solid"/>
+                      <a:round/>
+                      <a:headEnd type="none" w="med" len="med"/>
+                      <a:tailEnd type="none" w="med" len="med"/>
+                    </a:lnT>
+                    <a:lnB w="6350" cap="flat" cmpd="sng" algn="ctr">
+                      <a:solidFill>
+                        <a:srgbClr val="C9C9C4"/>
+                      </a:solidFill>
+                      <a:prstDash val="solid"/>
+                      <a:round/>
+                      <a:headEnd type="none" w="med" len="med"/>
+                      <a:tailEnd type="none" w="med" len="med"/>
+                    </a:lnB>
+                    <a:solidFill>
+                      <a:srgbClr val="FFFFFF"/>
+                    </a:solidFill>
+                  </a:tcPr>
+                </a:tc>
+              </a:tr>
+              <a:tr h="274320">
+                <a:tc>
+                  <a:txBody>
+                    <a:bodyPr/>
+                    <a:lstStyle/>
+                    <a:p>
+                      <a:pPr indent="0" marL="0">
+                        <a:buNone/>
+                      </a:pPr>
+                      <a:r>
+                        <a:rPr lang="en-US" sz="1050" dirty="0">
+                          <a:solidFill>
+                            <a:srgbClr val="1F1F1F"/>
+                          </a:solidFill>
+                          <a:latin typeface="Calibri" pitchFamily="34" charset="0"/>
+                          <a:ea typeface="Calibri" pitchFamily="34" charset="-122"/>
+                          <a:cs typeface="Calibri" pitchFamily="34" charset="-120"/>
+                        </a:rPr>
+                        <a:t>Not yet verified</a:t>
+                      </a:r>
+                      <a:endParaRPr lang="en-US" sz="1050" dirty="0">
+                        <a:latin typeface="Calibri" charset="0"/>
+                        <a:ea typeface="Calibri" charset="0"/>
+                        <a:cs typeface="Calibri" charset="0"/>
+                      </a:endParaRPr>
+                    </a:p>
+                  </a:txBody>
+                  <a:tcPr marL="45720" marR="45720" marT="45720" marB="45720" anchor="ctr">
+                    <a:lnL w="6350" cap="flat" cmpd="sng" algn="ctr">
+                      <a:solidFill>
+                        <a:srgbClr val="C9C9C4"/>
+                      </a:solidFill>
+                      <a:prstDash val="solid"/>
+                      <a:round/>
+                      <a:headEnd type="none" w="med" len="med"/>
+                      <a:tailEnd type="none" w="med" len="med"/>
+                    </a:lnL>
+                    <a:lnR w="6350" cap="flat" cmpd="sng" algn="ctr">
+                      <a:solidFill>
+                        <a:srgbClr val="C9C9C4"/>
+                      </a:solidFill>
+                      <a:prstDash val="solid"/>
+                      <a:round/>
+                      <a:headEnd type="none" w="med" len="med"/>
+                      <a:tailEnd type="none" w="med" len="med"/>
+                    </a:lnR>
+                    <a:lnT w="6350" cap="flat" cmpd="sng" algn="ctr">
+                      <a:solidFill>
+                        <a:srgbClr val="C9C9C4"/>
+                      </a:solidFill>
+                      <a:prstDash val="solid"/>
+                      <a:round/>
+                      <a:headEnd type="none" w="med" len="med"/>
+                      <a:tailEnd type="none" w="med" len="med"/>
+                    </a:lnT>
+                    <a:lnB w="6350" cap="flat" cmpd="sng" algn="ctr">
+                      <a:solidFill>
+                        <a:srgbClr val="C9C9C4"/>
+                      </a:solidFill>
+                      <a:prstDash val="solid"/>
+                      <a:round/>
+                      <a:headEnd type="none" w="med" len="med"/>
+                      <a:tailEnd type="none" w="med" len="med"/>
+                    </a:lnB>
+                    <a:solidFill>
+                      <a:srgbClr val="FFFFFF"/>
+                    </a:solidFill>
+                  </a:tcPr>
+                </a:tc>
+                <a:tc>
+                  <a:txBody>
+                    <a:bodyPr/>
+                    <a:lstStyle/>
+                    <a:p>
+                      <a:pPr indent="0" marL="0">
+                        <a:buNone/>
+                      </a:pPr>
+                      <a:r>
+                        <a:rPr lang="en-US" sz="1050" dirty="0">
+                          <a:solidFill>
+                            <a:srgbClr val="1F1F1F"/>
+                          </a:solidFill>
+                          <a:latin typeface="Calibri" pitchFamily="34" charset="0"/>
+                          <a:ea typeface="Calibri" pitchFamily="34" charset="-122"/>
+                          <a:cs typeface="Calibri" pitchFamily="34" charset="-120"/>
+                        </a:rPr>
+                        <a:t>The alternative-sheet charts in Excel itself (no Excel here); a first-open check is in the notes</a:t>
                       </a:r>
                       <a:endParaRPr lang="en-US" sz="1050" dirty="0">
                         <a:latin typeface="Calibri" charset="0"/>
@@ -8495,542 +8895,6 @@
           </a:graphicData>
         </a:graphic>
       </p:graphicFrame>
-    </p:spTree>
-  </p:cSld>
-  <p:clrMapOvr>
-    <a:masterClrMapping/>
-  </p:clrMapOvr>
-</p:sld>
-</file>
-
-<file path=ppt/slides/slide17.xml><?xml version="1.0" encoding="utf-8"?>
-<p:sld xmlns:a="http://schemas.openxmlformats.org/drawingml/2006/main" xmlns:r="http://schemas.openxmlformats.org/officeDocument/2006/relationships" xmlns:p="http://schemas.openxmlformats.org/presentationml/2006/main">
-  <p:cSld name="Slide 17">
-    <p:bg>
-      <p:bgPr>
-        <a:solidFill>
-          <a:srgbClr val="FFFFFF"/>
-        </a:solidFill>
-      </p:bgPr>
-    </p:bg>
-    <p:spTree>
-      <p:nvGrpSpPr>
-        <p:cNvPr id="1" name=""/>
-        <p:cNvGrpSpPr/>
-        <p:nvPr/>
-      </p:nvGrpSpPr>
-      <p:grpSpPr>
-        <a:xfrm>
-          <a:off x="0" y="0"/>
-          <a:ext cx="0" cy="0"/>
-          <a:chOff x="0" y="0"/>
-          <a:chExt cx="0" cy="0"/>
-        </a:xfrm>
-      </p:grpSpPr>
-      <p:sp>
-        <p:nvSpPr>
-          <p:cNvPr id="2" name="Text 0"/>
-          <p:cNvSpPr txBox="1"/>
-          <p:nvPr/>
-        </p:nvSpPr>
-        <p:spPr>
-          <a:xfrm>
-            <a:off x="457200" y="320040"/>
-            <a:ext cx="8229600" cy="640080"/>
-          </a:xfrm>
-          <a:prstGeom prst="rect">
-            <a:avLst/>
-          </a:prstGeom>
-          <a:noFill/>
-          <a:ln/>
-        </p:spPr>
-        <p:txBody>
-          <a:bodyPr wrap="square" lIns="0" tIns="0" rIns="0" bIns="0" rtlCol="0" anchor="t"/>
-          <a:lstStyle/>
-          <a:p>
-            <a:pPr indent="0" marL="0">
-              <a:buNone/>
-            </a:pPr>
-            <a:r>
-              <a:rPr lang="en-US" sz="2800" b="1" dirty="0">
-                <a:solidFill>
-                  <a:srgbClr val="1F1F1F"/>
-                </a:solidFill>
-                <a:latin typeface="Cambria" pitchFamily="34" charset="0"/>
-                <a:ea typeface="Cambria" pitchFamily="34" charset="-122"/>
-                <a:cs typeface="Cambria" pitchFamily="34" charset="-120"/>
-              </a:rPr>
-              <a:t>How TDOT uses it</a:t>
-            </a:r>
-            <a:endParaRPr lang="en-US" sz="2800" dirty="0"/>
-          </a:p>
-        </p:txBody>
-      </p:sp>
-      <p:sp>
-        <p:nvSpPr>
-          <p:cNvPr id="3" name="Text 1"/>
-          <p:cNvSpPr txBox="1"/>
-          <p:nvPr/>
-        </p:nvSpPr>
-        <p:spPr>
-          <a:xfrm>
-            <a:off x="457200" y="914400"/>
-            <a:ext cx="8229600" cy="365760"/>
-          </a:xfrm>
-          <a:prstGeom prst="rect">
-            <a:avLst/>
-          </a:prstGeom>
-          <a:noFill/>
-          <a:ln/>
-        </p:spPr>
-        <p:txBody>
-          <a:bodyPr wrap="square" lIns="0" tIns="0" rIns="0" bIns="0" rtlCol="0" anchor="ctr"/>
-          <a:lstStyle/>
-          <a:p>
-            <a:pPr indent="0" marL="0">
-              <a:buNone/>
-            </a:pPr>
-            <a:r>
-              <a:rPr lang="en-US" sz="1300" i="1" dirty="0">
-                <a:solidFill>
-                  <a:srgbClr val="5F5F5F"/>
-                </a:solidFill>
-                <a:latin typeface="Calibri" pitchFamily="34" charset="0"/>
-                <a:ea typeface="Calibri" pitchFamily="34" charset="-122"/>
-                <a:cs typeface="Calibri" pitchFamily="34" charset="-120"/>
-              </a:rPr>
-              <a:t>Excel only. No add-ins. The decision workbook has no macros at all.</a:t>
-            </a:r>
-            <a:endParaRPr lang="en-US" sz="1300" dirty="0"/>
-          </a:p>
-        </p:txBody>
-      </p:sp>
-      <p:sp>
-        <p:nvSpPr>
-          <p:cNvPr id="4" name="Shape 2"/>
-          <p:cNvSpPr/>
-          <p:nvPr/>
-        </p:nvSpPr>
-        <p:spPr>
-          <a:xfrm>
-            <a:off x="457200" y="1463040"/>
-            <a:ext cx="502920" cy="502920"/>
-          </a:xfrm>
-          <a:prstGeom prst="ellipse">
-            <a:avLst/>
-          </a:prstGeom>
-          <a:solidFill>
-            <a:srgbClr val="1D2733"/>
-          </a:solidFill>
-          <a:ln w="12700">
-            <a:solidFill>
-              <a:srgbClr val="1D2733"/>
-            </a:solidFill>
-            <a:prstDash val="solid"/>
-          </a:ln>
-        </p:spPr>
-      </p:sp>
-      <p:sp>
-        <p:nvSpPr>
-          <p:cNvPr id="5" name="Text 3"/>
-          <p:cNvSpPr txBox="1"/>
-          <p:nvPr/>
-        </p:nvSpPr>
-        <p:spPr>
-          <a:xfrm>
-            <a:off x="457200" y="1463040"/>
-            <a:ext cx="502920" cy="502920"/>
-          </a:xfrm>
-          <a:prstGeom prst="rect">
-            <a:avLst/>
-          </a:prstGeom>
-          <a:noFill/>
-          <a:ln/>
-        </p:spPr>
-        <p:txBody>
-          <a:bodyPr wrap="square" lIns="0" tIns="0" rIns="0" bIns="0" rtlCol="0" anchor="ctr"/>
-          <a:lstStyle/>
-          <a:p>
-            <a:pPr algn="ctr" indent="0" marL="0">
-              <a:buNone/>
-            </a:pPr>
-            <a:r>
-              <a:rPr lang="en-US" sz="1800" b="1" dirty="0">
-                <a:solidFill>
-                  <a:srgbClr val="FFFFFF"/>
-                </a:solidFill>
-                <a:latin typeface="Cambria" pitchFamily="34" charset="0"/>
-                <a:ea typeface="Cambria" pitchFamily="34" charset="-122"/>
-                <a:cs typeface="Cambria" pitchFamily="34" charset="-120"/>
-              </a:rPr>
-              <a:t>1</a:t>
-            </a:r>
-            <a:endParaRPr lang="en-US" sz="1800" dirty="0"/>
-          </a:p>
-        </p:txBody>
-      </p:sp>
-      <p:sp>
-        <p:nvSpPr>
-          <p:cNvPr id="6" name="Text 4"/>
-          <p:cNvSpPr txBox="1"/>
-          <p:nvPr/>
-        </p:nvSpPr>
-        <p:spPr>
-          <a:xfrm>
-            <a:off x="457200" y="2103120"/>
-            <a:ext cx="2560320" cy="457200"/>
-          </a:xfrm>
-          <a:prstGeom prst="rect">
-            <a:avLst/>
-          </a:prstGeom>
-          <a:noFill/>
-          <a:ln/>
-        </p:spPr>
-        <p:txBody>
-          <a:bodyPr wrap="square" lIns="0" tIns="0" rIns="0" bIns="0" rtlCol="0" anchor="ctr"/>
-          <a:lstStyle/>
-          <a:p>
-            <a:pPr indent="0" marL="0">
-              <a:buNone/>
-            </a:pPr>
-            <a:r>
-              <a:rPr lang="en-US" sz="1500" b="1" dirty="0">
-                <a:solidFill>
-                  <a:srgbClr val="1F1F1F"/>
-                </a:solidFill>
-                <a:latin typeface="Cambria" pitchFamily="34" charset="0"/>
-                <a:ea typeface="Cambria" pitchFamily="34" charset="-122"/>
-                <a:cs typeface="Cambria" pitchFamily="34" charset="-120"/>
-              </a:rPr>
-              <a:t>Run the framework as before</a:t>
-            </a:r>
-            <a:endParaRPr lang="en-US" sz="1500" dirty="0"/>
-          </a:p>
-        </p:txBody>
-      </p:sp>
-      <p:sp>
-        <p:nvSpPr>
-          <p:cNvPr id="7" name="Text 5"/>
-          <p:cNvSpPr txBox="1"/>
-          <p:nvPr/>
-        </p:nvSpPr>
-        <p:spPr>
-          <a:xfrm>
-            <a:off x="457200" y="2606040"/>
-            <a:ext cx="2560320" cy="1645920"/>
-          </a:xfrm>
-          <a:prstGeom prst="rect">
-            <a:avLst/>
-          </a:prstGeom>
-          <a:noFill/>
-          <a:ln/>
-        </p:spPr>
-        <p:txBody>
-          <a:bodyPr wrap="square" lIns="0" tIns="0" rIns="0" bIns="0" rtlCol="0" anchor="t"/>
-          <a:lstStyle/>
-          <a:p>
-            <a:pPr indent="0" marL="0">
-              <a:buNone/>
-            </a:pPr>
-            <a:r>
-              <a:rPr lang="en-US" sz="1200" dirty="0">
-                <a:solidFill>
-                  <a:srgbClr val="1F1F1F"/>
-                </a:solidFill>
-                <a:latin typeface="Calibri" pitchFamily="34" charset="0"/>
-                <a:ea typeface="Calibri" pitchFamily="34" charset="-122"/>
-                <a:cs typeface="Calibri" pitchFamily="34" charset="-120"/>
-              </a:rPr>
-              <a:t>Open v1.2.0, enable content, fill General Information, build alternatives with Alternative Setup. The Summary now shows categories, closures and the 7 percent flag.</a:t>
-            </a:r>
-            <a:endParaRPr lang="en-US" sz="1200" dirty="0"/>
-          </a:p>
-        </p:txBody>
-      </p:sp>
-      <p:sp>
-        <p:nvSpPr>
-          <p:cNvPr id="8" name="Shape 6"/>
-          <p:cNvSpPr/>
-          <p:nvPr/>
-        </p:nvSpPr>
-        <p:spPr>
-          <a:xfrm>
-            <a:off x="3246120" y="1463040"/>
-            <a:ext cx="502920" cy="502920"/>
-          </a:xfrm>
-          <a:prstGeom prst="ellipse">
-            <a:avLst/>
-          </a:prstGeom>
-          <a:solidFill>
-            <a:srgbClr val="1D2733"/>
-          </a:solidFill>
-          <a:ln w="12700">
-            <a:solidFill>
-              <a:srgbClr val="1D2733"/>
-            </a:solidFill>
-            <a:prstDash val="solid"/>
-          </a:ln>
-        </p:spPr>
-      </p:sp>
-      <p:sp>
-        <p:nvSpPr>
-          <p:cNvPr id="9" name="Text 7"/>
-          <p:cNvSpPr txBox="1"/>
-          <p:nvPr/>
-        </p:nvSpPr>
-        <p:spPr>
-          <a:xfrm>
-            <a:off x="3246120" y="1463040"/>
-            <a:ext cx="502920" cy="502920"/>
-          </a:xfrm>
-          <a:prstGeom prst="rect">
-            <a:avLst/>
-          </a:prstGeom>
-          <a:noFill/>
-          <a:ln/>
-        </p:spPr>
-        <p:txBody>
-          <a:bodyPr wrap="square" lIns="0" tIns="0" rIns="0" bIns="0" rtlCol="0" anchor="ctr"/>
-          <a:lstStyle/>
-          <a:p>
-            <a:pPr algn="ctr" indent="0" marL="0">
-              <a:buNone/>
-            </a:pPr>
-            <a:r>
-              <a:rPr lang="en-US" sz="1800" b="1" dirty="0">
-                <a:solidFill>
-                  <a:srgbClr val="FFFFFF"/>
-                </a:solidFill>
-                <a:latin typeface="Cambria" pitchFamily="34" charset="0"/>
-                <a:ea typeface="Cambria" pitchFamily="34" charset="-122"/>
-                <a:cs typeface="Cambria" pitchFamily="34" charset="-120"/>
-              </a:rPr>
-              <a:t>2</a:t>
-            </a:r>
-            <a:endParaRPr lang="en-US" sz="1800" dirty="0"/>
-          </a:p>
-        </p:txBody>
-      </p:sp>
-      <p:sp>
-        <p:nvSpPr>
-          <p:cNvPr id="10" name="Text 8"/>
-          <p:cNvSpPr txBox="1"/>
-          <p:nvPr/>
-        </p:nvSpPr>
-        <p:spPr>
-          <a:xfrm>
-            <a:off x="3246120" y="2103120"/>
-            <a:ext cx="2560320" cy="457200"/>
-          </a:xfrm>
-          <a:prstGeom prst="rect">
-            <a:avLst/>
-          </a:prstGeom>
-          <a:noFill/>
-          <a:ln/>
-        </p:spPr>
-        <p:txBody>
-          <a:bodyPr wrap="square" lIns="0" tIns="0" rIns="0" bIns="0" rtlCol="0" anchor="ctr"/>
-          <a:lstStyle/>
-          <a:p>
-            <a:pPr indent="0" marL="0">
-              <a:buNone/>
-            </a:pPr>
-            <a:r>
-              <a:rPr lang="en-US" sz="1500" b="1" dirty="0">
-                <a:solidFill>
-                  <a:srgbClr val="1F1F1F"/>
-                </a:solidFill>
-                <a:latin typeface="Cambria" pitchFamily="34" charset="0"/>
-                <a:ea typeface="Cambria" pitchFamily="34" charset="-122"/>
-                <a:cs typeface="Cambria" pitchFamily="34" charset="-120"/>
-              </a:rPr>
-              <a:t>Copy the TEMPLATE sheet</a:t>
-            </a:r>
-            <a:endParaRPr lang="en-US" sz="1500" dirty="0"/>
-          </a:p>
-        </p:txBody>
-      </p:sp>
-      <p:sp>
-        <p:nvSpPr>
-          <p:cNvPr id="11" name="Text 9"/>
-          <p:cNvSpPr txBox="1"/>
-          <p:nvPr/>
-        </p:nvSpPr>
-        <p:spPr>
-          <a:xfrm>
-            <a:off x="3246120" y="2606040"/>
-            <a:ext cx="2560320" cy="1645920"/>
-          </a:xfrm>
-          <a:prstGeom prst="rect">
-            <a:avLst/>
-          </a:prstGeom>
-          <a:noFill/>
-          <a:ln/>
-        </p:spPr>
-        <p:txBody>
-          <a:bodyPr wrap="square" lIns="0" tIns="0" rIns="0" bIns="0" rtlCol="0" anchor="t"/>
-          <a:lstStyle/>
-          <a:p>
-            <a:pPr indent="0" marL="0">
-              <a:buNone/>
-            </a:pPr>
-            <a:r>
-              <a:rPr lang="en-US" sz="1200" dirty="0">
-                <a:solidFill>
-                  <a:srgbClr val="1F1F1F"/>
-                </a:solidFill>
-                <a:latin typeface="Calibri" pitchFamily="34" charset="0"/>
-                <a:ea typeface="Calibri" pitchFamily="34" charset="-122"/>
-                <a:cs typeface="Calibri" pitchFamily="34" charset="-120"/>
-              </a:rPr>
-              <a:t>In the decision workbook, right-click TEMPLATE, Move or Copy, rename. Paste the base costs and closure days from each Alt sheet into the yellow cells.</a:t>
-            </a:r>
-            <a:endParaRPr lang="en-US" sz="1200" dirty="0"/>
-          </a:p>
-        </p:txBody>
-      </p:sp>
-      <p:sp>
-        <p:nvSpPr>
-          <p:cNvPr id="12" name="Shape 10"/>
-          <p:cNvSpPr/>
-          <p:nvPr/>
-        </p:nvSpPr>
-        <p:spPr>
-          <a:xfrm>
-            <a:off x="6035040" y="1463040"/>
-            <a:ext cx="502920" cy="502920"/>
-          </a:xfrm>
-          <a:prstGeom prst="ellipse">
-            <a:avLst/>
-          </a:prstGeom>
-          <a:solidFill>
-            <a:srgbClr val="1D2733"/>
-          </a:solidFill>
-          <a:ln w="12700">
-            <a:solidFill>
-              <a:srgbClr val="1D2733"/>
-            </a:solidFill>
-            <a:prstDash val="solid"/>
-          </a:ln>
-        </p:spPr>
-      </p:sp>
-      <p:sp>
-        <p:nvSpPr>
-          <p:cNvPr id="13" name="Text 11"/>
-          <p:cNvSpPr txBox="1"/>
-          <p:nvPr/>
-        </p:nvSpPr>
-        <p:spPr>
-          <a:xfrm>
-            <a:off x="6035040" y="1463040"/>
-            <a:ext cx="502920" cy="502920"/>
-          </a:xfrm>
-          <a:prstGeom prst="rect">
-            <a:avLst/>
-          </a:prstGeom>
-          <a:noFill/>
-          <a:ln/>
-        </p:spPr>
-        <p:txBody>
-          <a:bodyPr wrap="square" lIns="0" tIns="0" rIns="0" bIns="0" rtlCol="0" anchor="ctr"/>
-          <a:lstStyle/>
-          <a:p>
-            <a:pPr algn="ctr" indent="0" marL="0">
-              <a:buNone/>
-            </a:pPr>
-            <a:r>
-              <a:rPr lang="en-US" sz="1800" b="1" dirty="0">
-                <a:solidFill>
-                  <a:srgbClr val="FFFFFF"/>
-                </a:solidFill>
-                <a:latin typeface="Cambria" pitchFamily="34" charset="0"/>
-                <a:ea typeface="Cambria" pitchFamily="34" charset="-122"/>
-                <a:cs typeface="Cambria" pitchFamily="34" charset="-120"/>
-              </a:rPr>
-              <a:t>3</a:t>
-            </a:r>
-            <a:endParaRPr lang="en-US" sz="1800" dirty="0"/>
-          </a:p>
-        </p:txBody>
-      </p:sp>
-      <p:sp>
-        <p:nvSpPr>
-          <p:cNvPr id="14" name="Text 12"/>
-          <p:cNvSpPr txBox="1"/>
-          <p:nvPr/>
-        </p:nvSpPr>
-        <p:spPr>
-          <a:xfrm>
-            <a:off x="6035040" y="2103120"/>
-            <a:ext cx="2560320" cy="457200"/>
-          </a:xfrm>
-          <a:prstGeom prst="rect">
-            <a:avLst/>
-          </a:prstGeom>
-          <a:noFill/>
-          <a:ln/>
-        </p:spPr>
-        <p:txBody>
-          <a:bodyPr wrap="square" lIns="0" tIns="0" rIns="0" bIns="0" rtlCol="0" anchor="ctr"/>
-          <a:lstStyle/>
-          <a:p>
-            <a:pPr indent="0" marL="0">
-              <a:buNone/>
-            </a:pPr>
-            <a:r>
-              <a:rPr lang="en-US" sz="1500" b="1" dirty="0">
-                <a:solidFill>
-                  <a:srgbClr val="1F1F1F"/>
-                </a:solidFill>
-                <a:latin typeface="Cambria" pitchFamily="34" charset="0"/>
-                <a:ea typeface="Cambria" pitchFamily="34" charset="-122"/>
-                <a:cs typeface="Cambria" pitchFamily="34" charset="-120"/>
-              </a:rPr>
-              <a:t>Read the decision blocks</a:t>
-            </a:r>
-            <a:endParaRPr lang="en-US" sz="1500" dirty="0"/>
-          </a:p>
-        </p:txBody>
-      </p:sp>
-      <p:sp>
-        <p:nvSpPr>
-          <p:cNvPr id="15" name="Text 13"/>
-          <p:cNvSpPr txBox="1"/>
-          <p:nvPr/>
-        </p:nvSpPr>
-        <p:spPr>
-          <a:xfrm>
-            <a:off x="6035040" y="2606040"/>
-            <a:ext cx="2560320" cy="1645920"/>
-          </a:xfrm>
-          <a:prstGeom prst="rect">
-            <a:avLst/>
-          </a:prstGeom>
-          <a:noFill/>
-          <a:ln/>
-        </p:spPr>
-        <p:txBody>
-          <a:bodyPr wrap="square" lIns="0" tIns="0" rIns="0" bIns="0" rtlCol="0" anchor="t"/>
-          <a:lstStyle/>
-          <a:p>
-            <a:pPr indent="0" marL="0">
-              <a:buNone/>
-            </a:pPr>
-            <a:r>
-              <a:rPr lang="en-US" sz="1200" dirty="0">
-                <a:solidFill>
-                  <a:srgbClr val="1F1F1F"/>
-                </a:solidFill>
-                <a:latin typeface="Calibri" pitchFamily="34" charset="0"/>
-                <a:ea typeface="Calibri" pitchFamily="34" charset="-122"/>
-                <a:cs typeface="Calibri" pitchFamily="34" charset="-120"/>
-              </a:rPr>
-              <a:t>RESULTS, BREAK-EVEN VALUES, the scenario scorecard and the decision map. Change any yellow cell and every chart follows. F9 redraws the simulation.</a:t>
-            </a:r>
-            <a:endParaRPr lang="en-US" sz="1200" dirty="0"/>
-          </a:p>
-        </p:txBody>
-      </p:sp>
     </p:spTree>
   </p:cSld>
   <p:clrMapOvr>
@@ -9096,6 +8960,542 @@
                 <a:ea typeface="Cambria" pitchFamily="34" charset="-122"/>
                 <a:cs typeface="Cambria" pitchFamily="34" charset="-120"/>
               </a:rPr>
+              <a:t>How TDOT uses it</a:t>
+            </a:r>
+            <a:endParaRPr lang="en-US" sz="2800" dirty="0"/>
+          </a:p>
+        </p:txBody>
+      </p:sp>
+      <p:sp>
+        <p:nvSpPr>
+          <p:cNvPr id="3" name="Text 1"/>
+          <p:cNvSpPr txBox="1"/>
+          <p:nvPr/>
+        </p:nvSpPr>
+        <p:spPr>
+          <a:xfrm>
+            <a:off x="457200" y="914400"/>
+            <a:ext cx="8229600" cy="365760"/>
+          </a:xfrm>
+          <a:prstGeom prst="rect">
+            <a:avLst/>
+          </a:prstGeom>
+          <a:noFill/>
+          <a:ln/>
+        </p:spPr>
+        <p:txBody>
+          <a:bodyPr wrap="square" lIns="0" tIns="0" rIns="0" bIns="0" rtlCol="0" anchor="ctr"/>
+          <a:lstStyle/>
+          <a:p>
+            <a:pPr indent="0" marL="0">
+              <a:buNone/>
+            </a:pPr>
+            <a:r>
+              <a:rPr lang="en-US" sz="1300" i="1" dirty="0">
+                <a:solidFill>
+                  <a:srgbClr val="5F5F5F"/>
+                </a:solidFill>
+                <a:latin typeface="Calibri" pitchFamily="34" charset="0"/>
+                <a:ea typeface="Calibri" pitchFamily="34" charset="-122"/>
+                <a:cs typeface="Calibri" pitchFamily="34" charset="-120"/>
+              </a:rPr>
+              <a:t>Excel only. No add-ins. The decision workbook has no macros at all.</a:t>
+            </a:r>
+            <a:endParaRPr lang="en-US" sz="1300" dirty="0"/>
+          </a:p>
+        </p:txBody>
+      </p:sp>
+      <p:sp>
+        <p:nvSpPr>
+          <p:cNvPr id="4" name="Shape 2"/>
+          <p:cNvSpPr/>
+          <p:nvPr/>
+        </p:nvSpPr>
+        <p:spPr>
+          <a:xfrm>
+            <a:off x="457200" y="1463040"/>
+            <a:ext cx="502920" cy="502920"/>
+          </a:xfrm>
+          <a:prstGeom prst="ellipse">
+            <a:avLst/>
+          </a:prstGeom>
+          <a:solidFill>
+            <a:srgbClr val="1D2733"/>
+          </a:solidFill>
+          <a:ln w="12700">
+            <a:solidFill>
+              <a:srgbClr val="1D2733"/>
+            </a:solidFill>
+            <a:prstDash val="solid"/>
+          </a:ln>
+        </p:spPr>
+      </p:sp>
+      <p:sp>
+        <p:nvSpPr>
+          <p:cNvPr id="5" name="Text 3"/>
+          <p:cNvSpPr txBox="1"/>
+          <p:nvPr/>
+        </p:nvSpPr>
+        <p:spPr>
+          <a:xfrm>
+            <a:off x="457200" y="1463040"/>
+            <a:ext cx="502920" cy="502920"/>
+          </a:xfrm>
+          <a:prstGeom prst="rect">
+            <a:avLst/>
+          </a:prstGeom>
+          <a:noFill/>
+          <a:ln/>
+        </p:spPr>
+        <p:txBody>
+          <a:bodyPr wrap="square" lIns="0" tIns="0" rIns="0" bIns="0" rtlCol="0" anchor="ctr"/>
+          <a:lstStyle/>
+          <a:p>
+            <a:pPr algn="ctr" indent="0" marL="0">
+              <a:buNone/>
+            </a:pPr>
+            <a:r>
+              <a:rPr lang="en-US" sz="1800" b="1" dirty="0">
+                <a:solidFill>
+                  <a:srgbClr val="FFFFFF"/>
+                </a:solidFill>
+                <a:latin typeface="Cambria" pitchFamily="34" charset="0"/>
+                <a:ea typeface="Cambria" pitchFamily="34" charset="-122"/>
+                <a:cs typeface="Cambria" pitchFamily="34" charset="-120"/>
+              </a:rPr>
+              <a:t>1</a:t>
+            </a:r>
+            <a:endParaRPr lang="en-US" sz="1800" dirty="0"/>
+          </a:p>
+        </p:txBody>
+      </p:sp>
+      <p:sp>
+        <p:nvSpPr>
+          <p:cNvPr id="6" name="Text 4"/>
+          <p:cNvSpPr txBox="1"/>
+          <p:nvPr/>
+        </p:nvSpPr>
+        <p:spPr>
+          <a:xfrm>
+            <a:off x="457200" y="2103120"/>
+            <a:ext cx="2560320" cy="457200"/>
+          </a:xfrm>
+          <a:prstGeom prst="rect">
+            <a:avLst/>
+          </a:prstGeom>
+          <a:noFill/>
+          <a:ln/>
+        </p:spPr>
+        <p:txBody>
+          <a:bodyPr wrap="square" lIns="0" tIns="0" rIns="0" bIns="0" rtlCol="0" anchor="ctr"/>
+          <a:lstStyle/>
+          <a:p>
+            <a:pPr indent="0" marL="0">
+              <a:buNone/>
+            </a:pPr>
+            <a:r>
+              <a:rPr lang="en-US" sz="1500" b="1" dirty="0">
+                <a:solidFill>
+                  <a:srgbClr val="1F1F1F"/>
+                </a:solidFill>
+                <a:latin typeface="Cambria" pitchFamily="34" charset="0"/>
+                <a:ea typeface="Cambria" pitchFamily="34" charset="-122"/>
+                <a:cs typeface="Cambria" pitchFamily="34" charset="-120"/>
+              </a:rPr>
+              <a:t>Run the framework as before</a:t>
+            </a:r>
+            <a:endParaRPr lang="en-US" sz="1500" dirty="0"/>
+          </a:p>
+        </p:txBody>
+      </p:sp>
+      <p:sp>
+        <p:nvSpPr>
+          <p:cNvPr id="7" name="Text 5"/>
+          <p:cNvSpPr txBox="1"/>
+          <p:nvPr/>
+        </p:nvSpPr>
+        <p:spPr>
+          <a:xfrm>
+            <a:off x="457200" y="2606040"/>
+            <a:ext cx="2560320" cy="1645920"/>
+          </a:xfrm>
+          <a:prstGeom prst="rect">
+            <a:avLst/>
+          </a:prstGeom>
+          <a:noFill/>
+          <a:ln/>
+        </p:spPr>
+        <p:txBody>
+          <a:bodyPr wrap="square" lIns="0" tIns="0" rIns="0" bIns="0" rtlCol="0" anchor="t"/>
+          <a:lstStyle/>
+          <a:p>
+            <a:pPr indent="0" marL="0">
+              <a:buNone/>
+            </a:pPr>
+            <a:r>
+              <a:rPr lang="en-US" sz="1200" dirty="0">
+                <a:solidFill>
+                  <a:srgbClr val="1F1F1F"/>
+                </a:solidFill>
+                <a:latin typeface="Calibri" pitchFamily="34" charset="0"/>
+                <a:ea typeface="Calibri" pitchFamily="34" charset="-122"/>
+                <a:cs typeface="Calibri" pitchFamily="34" charset="-120"/>
+              </a:rPr>
+              <a:t>Open v1.2.0, enable content, fill General Information, build alternatives with Alternative Setup. Click View Summary: categories, closures, the 7 percent flag and five charts, no import needed.</a:t>
+            </a:r>
+            <a:endParaRPr lang="en-US" sz="1200" dirty="0"/>
+          </a:p>
+        </p:txBody>
+      </p:sp>
+      <p:sp>
+        <p:nvSpPr>
+          <p:cNvPr id="8" name="Shape 6"/>
+          <p:cNvSpPr/>
+          <p:nvPr/>
+        </p:nvSpPr>
+        <p:spPr>
+          <a:xfrm>
+            <a:off x="3246120" y="1463040"/>
+            <a:ext cx="502920" cy="502920"/>
+          </a:xfrm>
+          <a:prstGeom prst="ellipse">
+            <a:avLst/>
+          </a:prstGeom>
+          <a:solidFill>
+            <a:srgbClr val="1D2733"/>
+          </a:solidFill>
+          <a:ln w="12700">
+            <a:solidFill>
+              <a:srgbClr val="1D2733"/>
+            </a:solidFill>
+            <a:prstDash val="solid"/>
+          </a:ln>
+        </p:spPr>
+      </p:sp>
+      <p:sp>
+        <p:nvSpPr>
+          <p:cNvPr id="9" name="Text 7"/>
+          <p:cNvSpPr txBox="1"/>
+          <p:nvPr/>
+        </p:nvSpPr>
+        <p:spPr>
+          <a:xfrm>
+            <a:off x="3246120" y="1463040"/>
+            <a:ext cx="502920" cy="502920"/>
+          </a:xfrm>
+          <a:prstGeom prst="rect">
+            <a:avLst/>
+          </a:prstGeom>
+          <a:noFill/>
+          <a:ln/>
+        </p:spPr>
+        <p:txBody>
+          <a:bodyPr wrap="square" lIns="0" tIns="0" rIns="0" bIns="0" rtlCol="0" anchor="ctr"/>
+          <a:lstStyle/>
+          <a:p>
+            <a:pPr algn="ctr" indent="0" marL="0">
+              <a:buNone/>
+            </a:pPr>
+            <a:r>
+              <a:rPr lang="en-US" sz="1800" b="1" dirty="0">
+                <a:solidFill>
+                  <a:srgbClr val="FFFFFF"/>
+                </a:solidFill>
+                <a:latin typeface="Cambria" pitchFamily="34" charset="0"/>
+                <a:ea typeface="Cambria" pitchFamily="34" charset="-122"/>
+                <a:cs typeface="Cambria" pitchFamily="34" charset="-120"/>
+              </a:rPr>
+              <a:t>2</a:t>
+            </a:r>
+            <a:endParaRPr lang="en-US" sz="1800" dirty="0"/>
+          </a:p>
+        </p:txBody>
+      </p:sp>
+      <p:sp>
+        <p:nvSpPr>
+          <p:cNvPr id="10" name="Text 8"/>
+          <p:cNvSpPr txBox="1"/>
+          <p:nvPr/>
+        </p:nvSpPr>
+        <p:spPr>
+          <a:xfrm>
+            <a:off x="3246120" y="2103120"/>
+            <a:ext cx="2560320" cy="457200"/>
+          </a:xfrm>
+          <a:prstGeom prst="rect">
+            <a:avLst/>
+          </a:prstGeom>
+          <a:noFill/>
+          <a:ln/>
+        </p:spPr>
+        <p:txBody>
+          <a:bodyPr wrap="square" lIns="0" tIns="0" rIns="0" bIns="0" rtlCol="0" anchor="ctr"/>
+          <a:lstStyle/>
+          <a:p>
+            <a:pPr indent="0" marL="0">
+              <a:buNone/>
+            </a:pPr>
+            <a:r>
+              <a:rPr lang="en-US" sz="1500" b="1" dirty="0">
+                <a:solidFill>
+                  <a:srgbClr val="1F1F1F"/>
+                </a:solidFill>
+                <a:latin typeface="Cambria" pitchFamily="34" charset="0"/>
+                <a:ea typeface="Cambria" pitchFamily="34" charset="-122"/>
+                <a:cs typeface="Cambria" pitchFamily="34" charset="-120"/>
+              </a:rPr>
+              <a:t>Copy the TEMPLATE sheet</a:t>
+            </a:r>
+            <a:endParaRPr lang="en-US" sz="1500" dirty="0"/>
+          </a:p>
+        </p:txBody>
+      </p:sp>
+      <p:sp>
+        <p:nvSpPr>
+          <p:cNvPr id="11" name="Text 9"/>
+          <p:cNvSpPr txBox="1"/>
+          <p:nvPr/>
+        </p:nvSpPr>
+        <p:spPr>
+          <a:xfrm>
+            <a:off x="3246120" y="2606040"/>
+            <a:ext cx="2560320" cy="1645920"/>
+          </a:xfrm>
+          <a:prstGeom prst="rect">
+            <a:avLst/>
+          </a:prstGeom>
+          <a:noFill/>
+          <a:ln/>
+        </p:spPr>
+        <p:txBody>
+          <a:bodyPr wrap="square" lIns="0" tIns="0" rIns="0" bIns="0" rtlCol="0" anchor="t"/>
+          <a:lstStyle/>
+          <a:p>
+            <a:pPr indent="0" marL="0">
+              <a:buNone/>
+            </a:pPr>
+            <a:r>
+              <a:rPr lang="en-US" sz="1200" dirty="0">
+                <a:solidFill>
+                  <a:srgbClr val="1F1F1F"/>
+                </a:solidFill>
+                <a:latin typeface="Calibri" pitchFamily="34" charset="0"/>
+                <a:ea typeface="Calibri" pitchFamily="34" charset="-122"/>
+                <a:cs typeface="Calibri" pitchFamily="34" charset="-120"/>
+              </a:rPr>
+              <a:t>In the decision workbook, right-click TEMPLATE, Move or Copy, rename. Paste the base costs and closure days from each Alt sheet into the yellow cells.</a:t>
+            </a:r>
+            <a:endParaRPr lang="en-US" sz="1200" dirty="0"/>
+          </a:p>
+        </p:txBody>
+      </p:sp>
+      <p:sp>
+        <p:nvSpPr>
+          <p:cNvPr id="12" name="Shape 10"/>
+          <p:cNvSpPr/>
+          <p:nvPr/>
+        </p:nvSpPr>
+        <p:spPr>
+          <a:xfrm>
+            <a:off x="6035040" y="1463040"/>
+            <a:ext cx="502920" cy="502920"/>
+          </a:xfrm>
+          <a:prstGeom prst="ellipse">
+            <a:avLst/>
+          </a:prstGeom>
+          <a:solidFill>
+            <a:srgbClr val="1D2733"/>
+          </a:solidFill>
+          <a:ln w="12700">
+            <a:solidFill>
+              <a:srgbClr val="1D2733"/>
+            </a:solidFill>
+            <a:prstDash val="solid"/>
+          </a:ln>
+        </p:spPr>
+      </p:sp>
+      <p:sp>
+        <p:nvSpPr>
+          <p:cNvPr id="13" name="Text 11"/>
+          <p:cNvSpPr txBox="1"/>
+          <p:nvPr/>
+        </p:nvSpPr>
+        <p:spPr>
+          <a:xfrm>
+            <a:off x="6035040" y="1463040"/>
+            <a:ext cx="502920" cy="502920"/>
+          </a:xfrm>
+          <a:prstGeom prst="rect">
+            <a:avLst/>
+          </a:prstGeom>
+          <a:noFill/>
+          <a:ln/>
+        </p:spPr>
+        <p:txBody>
+          <a:bodyPr wrap="square" lIns="0" tIns="0" rIns="0" bIns="0" rtlCol="0" anchor="ctr"/>
+          <a:lstStyle/>
+          <a:p>
+            <a:pPr algn="ctr" indent="0" marL="0">
+              <a:buNone/>
+            </a:pPr>
+            <a:r>
+              <a:rPr lang="en-US" sz="1800" b="1" dirty="0">
+                <a:solidFill>
+                  <a:srgbClr val="FFFFFF"/>
+                </a:solidFill>
+                <a:latin typeface="Cambria" pitchFamily="34" charset="0"/>
+                <a:ea typeface="Cambria" pitchFamily="34" charset="-122"/>
+                <a:cs typeface="Cambria" pitchFamily="34" charset="-120"/>
+              </a:rPr>
+              <a:t>3</a:t>
+            </a:r>
+            <a:endParaRPr lang="en-US" sz="1800" dirty="0"/>
+          </a:p>
+        </p:txBody>
+      </p:sp>
+      <p:sp>
+        <p:nvSpPr>
+          <p:cNvPr id="14" name="Text 12"/>
+          <p:cNvSpPr txBox="1"/>
+          <p:nvPr/>
+        </p:nvSpPr>
+        <p:spPr>
+          <a:xfrm>
+            <a:off x="6035040" y="2103120"/>
+            <a:ext cx="2560320" cy="457200"/>
+          </a:xfrm>
+          <a:prstGeom prst="rect">
+            <a:avLst/>
+          </a:prstGeom>
+          <a:noFill/>
+          <a:ln/>
+        </p:spPr>
+        <p:txBody>
+          <a:bodyPr wrap="square" lIns="0" tIns="0" rIns="0" bIns="0" rtlCol="0" anchor="ctr"/>
+          <a:lstStyle/>
+          <a:p>
+            <a:pPr indent="0" marL="0">
+              <a:buNone/>
+            </a:pPr>
+            <a:r>
+              <a:rPr lang="en-US" sz="1500" b="1" dirty="0">
+                <a:solidFill>
+                  <a:srgbClr val="1F1F1F"/>
+                </a:solidFill>
+                <a:latin typeface="Cambria" pitchFamily="34" charset="0"/>
+                <a:ea typeface="Cambria" pitchFamily="34" charset="-122"/>
+                <a:cs typeface="Cambria" pitchFamily="34" charset="-120"/>
+              </a:rPr>
+              <a:t>Read the decision blocks</a:t>
+            </a:r>
+            <a:endParaRPr lang="en-US" sz="1500" dirty="0"/>
+          </a:p>
+        </p:txBody>
+      </p:sp>
+      <p:sp>
+        <p:nvSpPr>
+          <p:cNvPr id="15" name="Text 13"/>
+          <p:cNvSpPr txBox="1"/>
+          <p:nvPr/>
+        </p:nvSpPr>
+        <p:spPr>
+          <a:xfrm>
+            <a:off x="6035040" y="2606040"/>
+            <a:ext cx="2560320" cy="1645920"/>
+          </a:xfrm>
+          <a:prstGeom prst="rect">
+            <a:avLst/>
+          </a:prstGeom>
+          <a:noFill/>
+          <a:ln/>
+        </p:spPr>
+        <p:txBody>
+          <a:bodyPr wrap="square" lIns="0" tIns="0" rIns="0" bIns="0" rtlCol="0" anchor="t"/>
+          <a:lstStyle/>
+          <a:p>
+            <a:pPr indent="0" marL="0">
+              <a:buNone/>
+            </a:pPr>
+            <a:r>
+              <a:rPr lang="en-US" sz="1200" dirty="0">
+                <a:solidFill>
+                  <a:srgbClr val="1F1F1F"/>
+                </a:solidFill>
+                <a:latin typeface="Calibri" pitchFamily="34" charset="0"/>
+                <a:ea typeface="Calibri" pitchFamily="34" charset="-122"/>
+                <a:cs typeface="Calibri" pitchFamily="34" charset="-120"/>
+              </a:rPr>
+              <a:t>RESULTS, BREAK-EVEN VALUES, the scenario scorecard and the decision map. Change any yellow cell and every chart follows. F9 redraws the simulation.</a:t>
+            </a:r>
+            <a:endParaRPr lang="en-US" sz="1200" dirty="0"/>
+          </a:p>
+        </p:txBody>
+      </p:sp>
+    </p:spTree>
+  </p:cSld>
+  <p:clrMapOvr>
+    <a:masterClrMapping/>
+  </p:clrMapOvr>
+</p:sld>
+</file>
+
+<file path=ppt/slides/slide19.xml><?xml version="1.0" encoding="utf-8"?>
+<p:sld xmlns:a="http://schemas.openxmlformats.org/drawingml/2006/main" xmlns:r="http://schemas.openxmlformats.org/officeDocument/2006/relationships" xmlns:p="http://schemas.openxmlformats.org/presentationml/2006/main">
+  <p:cSld name="Slide 19">
+    <p:bg>
+      <p:bgPr>
+        <a:solidFill>
+          <a:srgbClr val="FFFFFF"/>
+        </a:solidFill>
+      </p:bgPr>
+    </p:bg>
+    <p:spTree>
+      <p:nvGrpSpPr>
+        <p:cNvPr id="1" name=""/>
+        <p:cNvGrpSpPr/>
+        <p:nvPr/>
+      </p:nvGrpSpPr>
+      <p:grpSpPr>
+        <a:xfrm>
+          <a:off x="0" y="0"/>
+          <a:ext cx="0" cy="0"/>
+          <a:chOff x="0" y="0"/>
+          <a:chExt cx="0" cy="0"/>
+        </a:xfrm>
+      </p:grpSpPr>
+      <p:sp>
+        <p:nvSpPr>
+          <p:cNvPr id="2" name="Text 0"/>
+          <p:cNvSpPr txBox="1"/>
+          <p:nvPr/>
+        </p:nvSpPr>
+        <p:spPr>
+          <a:xfrm>
+            <a:off x="457200" y="320040"/>
+            <a:ext cx="8229600" cy="640080"/>
+          </a:xfrm>
+          <a:prstGeom prst="rect">
+            <a:avLst/>
+          </a:prstGeom>
+          <a:noFill/>
+          <a:ln/>
+        </p:spPr>
+        <p:txBody>
+          <a:bodyPr wrap="square" lIns="0" tIns="0" rIns="0" bIns="0" rtlCol="0" anchor="t"/>
+          <a:lstStyle/>
+          <a:p>
+            <a:pPr indent="0" marL="0">
+              <a:buNone/>
+            </a:pPr>
+            <a:r>
+              <a:rPr lang="en-US" sz="2800" b="1" dirty="0">
+                <a:solidFill>
+                  <a:srgbClr val="1F1F1F"/>
+                </a:solidFill>
+                <a:latin typeface="Cambria" pitchFamily="34" charset="0"/>
+                <a:ea typeface="Cambria" pitchFamily="34" charset="-122"/>
+                <a:cs typeface="Cambria" pitchFamily="34" charset="-120"/>
+              </a:rPr>
               <a:t>Open items</a:t>
             </a:r>
             <a:endParaRPr lang="en-US" sz="2800" dirty="0"/>
@@ -9398,7 +9798,7 @@
                 <a:ea typeface="Calibri" pitchFamily="34" charset="-122"/>
                 <a:cs typeface="Calibri" pitchFamily="34" charset="-120"/>
               </a:rPr>
-              <a:t>First open in Excel: run the six-step check, import Output.bas</a:t>
+              <a:t>First open in Excel: run the first-open check in the notes</a:t>
             </a:r>
             <a:endParaRPr lang="en-US" sz="1150" dirty="0"/>
           </a:p>
@@ -9470,155 +9870,6 @@
               <a:t>Optional later: a no-macro web version would remove the ActiveX problem entirely</a:t>
             </a:r>
             <a:endParaRPr lang="en-US" sz="1150" dirty="0"/>
-          </a:p>
-        </p:txBody>
-      </p:sp>
-    </p:spTree>
-  </p:cSld>
-  <p:clrMapOvr>
-    <a:masterClrMapping/>
-  </p:clrMapOvr>
-</p:sld>
-</file>
-
-<file path=ppt/slides/slide19.xml><?xml version="1.0" encoding="utf-8"?>
-<p:sld xmlns:a="http://schemas.openxmlformats.org/drawingml/2006/main" xmlns:r="http://schemas.openxmlformats.org/officeDocument/2006/relationships" xmlns:p="http://schemas.openxmlformats.org/presentationml/2006/main">
-  <p:cSld name="Slide 19">
-    <p:bg>
-      <p:bgPr>
-        <a:solidFill>
-          <a:srgbClr val="1D2733"/>
-        </a:solidFill>
-      </p:bgPr>
-    </p:bg>
-    <p:spTree>
-      <p:nvGrpSpPr>
-        <p:cNvPr id="1" name=""/>
-        <p:cNvGrpSpPr/>
-        <p:nvPr/>
-      </p:nvGrpSpPr>
-      <p:grpSpPr>
-        <a:xfrm>
-          <a:off x="0" y="0"/>
-          <a:ext cx="0" cy="0"/>
-          <a:chOff x="0" y="0"/>
-          <a:chExt cx="0" cy="0"/>
-        </a:xfrm>
-      </p:grpSpPr>
-      <p:sp>
-        <p:nvSpPr>
-          <p:cNvPr id="2" name="Text 0"/>
-          <p:cNvSpPr txBox="1"/>
-          <p:nvPr/>
-        </p:nvSpPr>
-        <p:spPr>
-          <a:xfrm>
-            <a:off x="548640" y="1097280"/>
-            <a:ext cx="8046720" cy="548640"/>
-          </a:xfrm>
-          <a:prstGeom prst="rect">
-            <a:avLst/>
-          </a:prstGeom>
-          <a:noFill/>
-          <a:ln/>
-        </p:spPr>
-        <p:txBody>
-          <a:bodyPr wrap="square" lIns="0" tIns="0" rIns="0" bIns="0" rtlCol="0" anchor="ctr"/>
-          <a:lstStyle/>
-          <a:p>
-            <a:pPr indent="0" marL="0">
-              <a:buNone/>
-            </a:pPr>
-            <a:r>
-              <a:rPr lang="en-US" sz="1400" i="1" dirty="0">
-                <a:solidFill>
-                  <a:srgbClr val="AEB8C4"/>
-                </a:solidFill>
-                <a:latin typeface="Calibri" pitchFamily="34" charset="0"/>
-                <a:ea typeface="Calibri" pitchFamily="34" charset="-122"/>
-                <a:cs typeface="Calibri" pitchFamily="34" charset="-120"/>
-              </a:rPr>
-              <a:t>In one line</a:t>
-            </a:r>
-            <a:endParaRPr lang="en-US" sz="1400" dirty="0"/>
-          </a:p>
-        </p:txBody>
-      </p:sp>
-      <p:sp>
-        <p:nvSpPr>
-          <p:cNvPr id="3" name="Text 1"/>
-          <p:cNvSpPr txBox="1"/>
-          <p:nvPr/>
-        </p:nvSpPr>
-        <p:spPr>
-          <a:xfrm>
-            <a:off x="548640" y="1645920"/>
-            <a:ext cx="8046720" cy="1463040"/>
-          </a:xfrm>
-          <a:prstGeom prst="rect">
-            <a:avLst/>
-          </a:prstGeom>
-          <a:noFill/>
-          <a:ln/>
-        </p:spPr>
-        <p:txBody>
-          <a:bodyPr wrap="square" lIns="0" tIns="0" rIns="0" bIns="0" rtlCol="0" anchor="t"/>
-          <a:lstStyle/>
-          <a:p>
-            <a:pPr indent="0" marL="0">
-              <a:buNone/>
-            </a:pPr>
-            <a:r>
-              <a:rPr lang="en-US" sz="2600" b="1" dirty="0">
-                <a:solidFill>
-                  <a:srgbClr val="FFFFFF"/>
-                </a:solidFill>
-                <a:latin typeface="Cambria" pitchFamily="34" charset="0"/>
-                <a:ea typeface="Cambria" pitchFamily="34" charset="-122"/>
-                <a:cs typeface="Cambria" pitchFamily="34" charset="-120"/>
-              </a:rPr>
-              <a:t>The tool now computes what it says it computes, shows why one alternative wins, and shows how many runway days that costs.</a:t>
-            </a:r>
-            <a:endParaRPr lang="en-US" sz="2600" dirty="0"/>
-          </a:p>
-        </p:txBody>
-      </p:sp>
-      <p:sp>
-        <p:nvSpPr>
-          <p:cNvPr id="4" name="Text 2"/>
-          <p:cNvSpPr txBox="1"/>
-          <p:nvPr/>
-        </p:nvSpPr>
-        <p:spPr>
-          <a:xfrm>
-            <a:off x="548640" y="4023360"/>
-            <a:ext cx="8046720" cy="548640"/>
-          </a:xfrm>
-          <a:prstGeom prst="rect">
-            <a:avLst/>
-          </a:prstGeom>
-          <a:noFill/>
-          <a:ln/>
-        </p:spPr>
-        <p:txBody>
-          <a:bodyPr wrap="square" lIns="0" tIns="0" rIns="0" bIns="0" rtlCol="0" anchor="ctr"/>
-          <a:lstStyle/>
-          <a:p>
-            <a:pPr indent="0" marL="0">
-              <a:buNone/>
-            </a:pPr>
-            <a:r>
-              <a:rPr lang="en-US" sz="1100" dirty="0">
-                <a:solidFill>
-                  <a:srgbClr val="AEB8C4"/>
-                </a:solidFill>
-                <a:latin typeface="Calibri" pitchFamily="34" charset="0"/>
-                <a:ea typeface="Calibri" pitchFamily="34" charset="-122"/>
-                <a:cs typeface="Calibri" pitchFamily="34" charset="-120"/>
-              </a:rPr>
-              <a:t>Deliverables: TDOA_LCCA_Framework_v1.2.0_ARA_09112026.xlsm  |  Output.bas  |  TDOT_LCCA_Decision_Workbook.xlsx  |  change notes</a:t>
-            </a:r>
-            <a:endParaRPr lang="en-US" sz="1100" dirty="0"/>
           </a:p>
         </p:txBody>
       </p:sp>
@@ -10228,6 +10479,155 @@
               <a:t>Full recalculation of every workbook with LibreOffice Calc before release</a:t>
             </a:r>
             <a:endParaRPr lang="en-US" sz="1150" dirty="0"/>
+          </a:p>
+        </p:txBody>
+      </p:sp>
+    </p:spTree>
+  </p:cSld>
+  <p:clrMapOvr>
+    <a:masterClrMapping/>
+  </p:clrMapOvr>
+</p:sld>
+</file>
+
+<file path=ppt/slides/slide20.xml><?xml version="1.0" encoding="utf-8"?>
+<p:sld xmlns:a="http://schemas.openxmlformats.org/drawingml/2006/main" xmlns:r="http://schemas.openxmlformats.org/officeDocument/2006/relationships" xmlns:p="http://schemas.openxmlformats.org/presentationml/2006/main">
+  <p:cSld name="Slide 20">
+    <p:bg>
+      <p:bgPr>
+        <a:solidFill>
+          <a:srgbClr val="1D2733"/>
+        </a:solidFill>
+      </p:bgPr>
+    </p:bg>
+    <p:spTree>
+      <p:nvGrpSpPr>
+        <p:cNvPr id="1" name=""/>
+        <p:cNvGrpSpPr/>
+        <p:nvPr/>
+      </p:nvGrpSpPr>
+      <p:grpSpPr>
+        <a:xfrm>
+          <a:off x="0" y="0"/>
+          <a:ext cx="0" cy="0"/>
+          <a:chOff x="0" y="0"/>
+          <a:chExt cx="0" cy="0"/>
+        </a:xfrm>
+      </p:grpSpPr>
+      <p:sp>
+        <p:nvSpPr>
+          <p:cNvPr id="2" name="Text 0"/>
+          <p:cNvSpPr txBox="1"/>
+          <p:nvPr/>
+        </p:nvSpPr>
+        <p:spPr>
+          <a:xfrm>
+            <a:off x="548640" y="1097280"/>
+            <a:ext cx="8046720" cy="548640"/>
+          </a:xfrm>
+          <a:prstGeom prst="rect">
+            <a:avLst/>
+          </a:prstGeom>
+          <a:noFill/>
+          <a:ln/>
+        </p:spPr>
+        <p:txBody>
+          <a:bodyPr wrap="square" lIns="0" tIns="0" rIns="0" bIns="0" rtlCol="0" anchor="ctr"/>
+          <a:lstStyle/>
+          <a:p>
+            <a:pPr indent="0" marL="0">
+              <a:buNone/>
+            </a:pPr>
+            <a:r>
+              <a:rPr lang="en-US" sz="1400" i="1" dirty="0">
+                <a:solidFill>
+                  <a:srgbClr val="AEB8C4"/>
+                </a:solidFill>
+                <a:latin typeface="Calibri" pitchFamily="34" charset="0"/>
+                <a:ea typeface="Calibri" pitchFamily="34" charset="-122"/>
+                <a:cs typeface="Calibri" pitchFamily="34" charset="-120"/>
+              </a:rPr>
+              <a:t>In one line</a:t>
+            </a:r>
+            <a:endParaRPr lang="en-US" sz="1400" dirty="0"/>
+          </a:p>
+        </p:txBody>
+      </p:sp>
+      <p:sp>
+        <p:nvSpPr>
+          <p:cNvPr id="3" name="Text 1"/>
+          <p:cNvSpPr txBox="1"/>
+          <p:nvPr/>
+        </p:nvSpPr>
+        <p:spPr>
+          <a:xfrm>
+            <a:off x="548640" y="1645920"/>
+            <a:ext cx="8046720" cy="1463040"/>
+          </a:xfrm>
+          <a:prstGeom prst="rect">
+            <a:avLst/>
+          </a:prstGeom>
+          <a:noFill/>
+          <a:ln/>
+        </p:spPr>
+        <p:txBody>
+          <a:bodyPr wrap="square" lIns="0" tIns="0" rIns="0" bIns="0" rtlCol="0" anchor="t"/>
+          <a:lstStyle/>
+          <a:p>
+            <a:pPr indent="0" marL="0">
+              <a:buNone/>
+            </a:pPr>
+            <a:r>
+              <a:rPr lang="en-US" sz="2600" b="1" dirty="0">
+                <a:solidFill>
+                  <a:srgbClr val="FFFFFF"/>
+                </a:solidFill>
+                <a:latin typeface="Cambria" pitchFamily="34" charset="0"/>
+                <a:ea typeface="Cambria" pitchFamily="34" charset="-122"/>
+                <a:cs typeface="Cambria" pitchFamily="34" charset="-120"/>
+              </a:rPr>
+              <a:t>The tool now computes what it says it computes, shows why one alternative wins, and shows how many runway days that costs.</a:t>
+            </a:r>
+            <a:endParaRPr lang="en-US" sz="2600" dirty="0"/>
+          </a:p>
+        </p:txBody>
+      </p:sp>
+      <p:sp>
+        <p:nvSpPr>
+          <p:cNvPr id="4" name="Text 2"/>
+          <p:cNvSpPr txBox="1"/>
+          <p:nvPr/>
+        </p:nvSpPr>
+        <p:spPr>
+          <a:xfrm>
+            <a:off x="548640" y="4023360"/>
+            <a:ext cx="8046720" cy="548640"/>
+          </a:xfrm>
+          <a:prstGeom prst="rect">
+            <a:avLst/>
+          </a:prstGeom>
+          <a:noFill/>
+          <a:ln/>
+        </p:spPr>
+        <p:txBody>
+          <a:bodyPr wrap="square" lIns="0" tIns="0" rIns="0" bIns="0" rtlCol="0" anchor="ctr"/>
+          <a:lstStyle/>
+          <a:p>
+            <a:pPr indent="0" marL="0">
+              <a:buNone/>
+            </a:pPr>
+            <a:r>
+              <a:rPr lang="en-US" sz="1100" dirty="0">
+                <a:solidFill>
+                  <a:srgbClr val="AEB8C4"/>
+                </a:solidFill>
+                <a:latin typeface="Calibri" pitchFamily="34" charset="0"/>
+                <a:ea typeface="Calibri" pitchFamily="34" charset="-122"/>
+                <a:cs typeface="Calibri" pitchFamily="34" charset="-120"/>
+              </a:rPr>
+              <a:t>Deliverables: TDOA_LCCA_Framework_v1.2.0_ARA_09112026.xlsm  |  TDOT_LCCA_Decision_Workbook.xlsx  |  Technical Change Record  |  change notes</a:t>
+            </a:r>
+            <a:endParaRPr lang="en-US" sz="1100" dirty="0"/>
           </a:p>
         </p:txBody>
       </p:sp>

</xml_diff>

<commit_message>
Polish v1.2.0 Summary: styled View Summary button, chart axis fixes, notes
- General Information: "LCCA Summary:" label (B44) and dark "View Summary"
  button cell (D44) styled like the Summary buttons, replacing plain text
- Summary charts 1 and 3: category labels moved below the negative salvage
  bars; chart 2 rate axis shown as percent
- Change notes rewritten for the self-contained build (no Output.bas import)
- Diff, change record, deck and MBT render regenerated

Co-Authored-By: Claude Fable 5.1 <noreply@anthropic.com>
Claude-Session: https://claude.ai/code/session_01JrCXNd278qC95SDvCCWbYM
</commit_message>
<xml_diff>
--- a/tdot-lcca/TDOT_LCCA_Review_and_v1.2.0_Update.pptx
+++ b/tdot-lcca/TDOT_LCCA_Review_and_v1.2.0_Update.pptx
@@ -3843,8 +3843,8 @@
         </p:blipFill>
         <p:spPr>
           <a:xfrm>
-            <a:off x="1143000" y="1234440"/>
-            <a:ext cx="6858000" cy="3345366"/>
+            <a:off x="822960" y="1234440"/>
+            <a:ext cx="7498080" cy="3442645"/>
           </a:xfrm>
           <a:prstGeom prst="rect">
             <a:avLst/>
@@ -3859,7 +3859,7 @@
         </p:nvSpPr>
         <p:spPr>
           <a:xfrm>
-            <a:off x="457200" y="4625526"/>
+            <a:off x="457200" y="4722805"/>
             <a:ext cx="8229600" cy="411480"/>
           </a:xfrm>
           <a:prstGeom prst="rect">
@@ -3884,7 +3884,7 @@
                 <a:ea typeface="Calibri" pitchFamily="34" charset="-122"/>
                 <a:cs typeface="Calibri" pitchFamily="34" charset="-120"/>
               </a:rPr>
-              <a:t>Buttons at top left return to General Information and Instructions; a "View Summary" button sits under Alternative Setup. Chart data lives in columns W onward, marked "do not edit".</a:t>
+              <a:t>Buttons at top left return to General Information and Instructions; a matching "View Summary" button sits under Alternative Setup. Chart data lives in columns W onward, marked "do not edit".</a:t>
             </a:r>
             <a:endParaRPr lang="en-US" sz="1050" dirty="0"/>
           </a:p>

</xml_diff>

<commit_message>
Scripted click-through of v1.2.0; period-aware closure days; verdict wording
- Summary Q column counts closure days inside the analysis period (by-year
  block), falling back to F4:F10 when lost revenue is off
- Verdict line reads "only one alternative so far" instead of margin $0
- verification/uno_walkthrough.py drives LibreOffice through the UNO API:
  follows every button, changes rate, period, indirect flag, airport, and
  removes alternatives; report saved alongside
- Change record, deck and notes updated with the click-through results

Co-Authored-By: Claude Fable 5.1 <noreply@anthropic.com>
Claude-Session: https://claude.ai/code/session_01JrCXNd278qC95SDvCCWbYM
</commit_message>
<xml_diff>
--- a/tdot-lcca/TDOT_LCCA_Review_and_v1.2.0_Update.pptx
+++ b/tdot-lcca/TDOT_LCCA_Review_and_v1.2.0_Update.pptx
@@ -7500,7 +7500,7 @@
           </p:nvPr>
         </p:nvGraphicFramePr>
         <p:xfrm>
-          <a:off x="457200" y="1188720"/>
+          <a:off x="457200" y="1097280"/>
           <a:ext cx="8229600" cy="914400"/>
         </p:xfrm>
         <a:graphic>
@@ -7508,8 +7508,8 @@
             <a:tbl>
               <a:tblPr/>
               <a:tblGrid>
-                <a:gridCol w="3291840"/>
-                <a:gridCol w="4937760"/>
+                <a:gridCol w="3108960"/>
+                <a:gridCol w="5120640"/>
               </a:tblGrid>
               <a:tr h="274320">
                 <a:tc>
@@ -7521,7 +7521,7 @@
                         <a:buNone/>
                       </a:pPr>
                       <a:r>
-                        <a:rPr lang="en-US" sz="1050" b="1" dirty="0">
+                        <a:rPr lang="en-US" sz="1000" b="1" dirty="0">
                           <a:solidFill>
                             <a:srgbClr val="1F1F1F"/>
                           </a:solidFill>
@@ -7531,7 +7531,7 @@
                         </a:rPr>
                         <a:t>Check</a:t>
                       </a:r>
-                      <a:endParaRPr lang="en-US" sz="1050" dirty="0">
+                      <a:endParaRPr lang="en-US" sz="1000" dirty="0">
                         <a:latin typeface="Calibri" charset="0"/>
                         <a:ea typeface="Calibri" charset="0"/>
                         <a:cs typeface="Calibri" charset="0"/>
@@ -7589,7 +7589,7 @@
                         <a:buNone/>
                       </a:pPr>
                       <a:r>
-                        <a:rPr lang="en-US" sz="1050" b="1" dirty="0">
+                        <a:rPr lang="en-US" sz="1000" b="1" dirty="0">
                           <a:solidFill>
                             <a:srgbClr val="1F1F1F"/>
                           </a:solidFill>
@@ -7599,7 +7599,7 @@
                         </a:rPr>
                         <a:t>Result</a:t>
                       </a:r>
-                      <a:endParaRPr lang="en-US" sz="1050" dirty="0">
+                      <a:endParaRPr lang="en-US" sz="1000" dirty="0">
                         <a:latin typeface="Calibri" charset="0"/>
                         <a:ea typeface="Calibri" charset="0"/>
                         <a:cs typeface="Calibri" charset="0"/>
@@ -7659,7 +7659,7 @@
                         <a:buNone/>
                       </a:pPr>
                       <a:r>
-                        <a:rPr lang="en-US" sz="1050" dirty="0">
+                        <a:rPr lang="en-US" sz="1000" dirty="0">
                           <a:solidFill>
                             <a:srgbClr val="1F1F1F"/>
                           </a:solidFill>
@@ -7669,7 +7669,7 @@
                         </a:rPr>
                         <a:t>Framework v1.2.0, full recalculation in LibreOffice Calc</a:t>
                       </a:r>
-                      <a:endParaRPr lang="en-US" sz="1050" dirty="0">
+                      <a:endParaRPr lang="en-US" sz="1000" dirty="0">
                         <a:latin typeface="Calibri" charset="0"/>
                         <a:ea typeface="Calibri" charset="0"/>
                         <a:cs typeface="Calibri" charset="0"/>
@@ -7727,7 +7727,7 @@
                         <a:buNone/>
                       </a:pPr>
                       <a:r>
-                        <a:rPr lang="en-US" sz="1050" dirty="0">
+                        <a:rPr lang="en-US" sz="1000" dirty="0">
                           <a:solidFill>
                             <a:srgbClr val="1F1F1F"/>
                           </a:solidFill>
@@ -7737,7 +7737,7 @@
                         </a:rPr>
                         <a:t>2,240 formulas incl. the new Summary, 0 errors (v1.1.2 shows 99 error cells under the same recalc)</a:t>
                       </a:r>
-                      <a:endParaRPr lang="en-US" sz="1050" dirty="0">
+                      <a:endParaRPr lang="en-US" sz="1000" dirty="0">
                         <a:latin typeface="Calibri" charset="0"/>
                         <a:ea typeface="Calibri" charset="0"/>
                         <a:cs typeface="Calibri" charset="0"/>
@@ -7797,7 +7797,7 @@
                         <a:buNone/>
                       </a:pPr>
                       <a:r>
-                        <a:rPr lang="en-US" sz="1050" dirty="0">
+                        <a:rPr lang="en-US" sz="1000" dirty="0">
                           <a:solidFill>
                             <a:srgbClr val="1F1F1F"/>
                           </a:solidFill>
@@ -7807,7 +7807,7 @@
                         </a:rPr>
                         <a:t>Patch applied to the populated MBT workbook</a:t>
                       </a:r>
-                      <a:endParaRPr lang="en-US" sz="1050" dirty="0">
+                      <a:endParaRPr lang="en-US" sz="1000" dirty="0">
                         <a:latin typeface="Calibri" charset="0"/>
                         <a:ea typeface="Calibri" charset="0"/>
                         <a:cs typeface="Calibri" charset="0"/>
@@ -7865,7 +7865,7 @@
                         <a:buNone/>
                       </a:pPr>
                       <a:r>
-                        <a:rPr lang="en-US" sz="1050" dirty="0">
+                        <a:rPr lang="en-US" sz="1000" dirty="0">
                           <a:solidFill>
                             <a:srgbClr val="1F1F1F"/>
                           </a:solidFill>
@@ -7875,7 +7875,7 @@
                         </a:rPr>
                         <a:t>NPW unchanged: $8,809,266 and $8,028,734; PCC blank rows now 0, not #N/A</a:t>
                       </a:r>
-                      <a:endParaRPr lang="en-US" sz="1050" dirty="0">
+                      <a:endParaRPr lang="en-US" sz="1000" dirty="0">
                         <a:latin typeface="Calibri" charset="0"/>
                         <a:ea typeface="Calibri" charset="0"/>
                         <a:cs typeface="Calibri" charset="0"/>
@@ -7935,7 +7935,7 @@
                         <a:buNone/>
                       </a:pPr>
                       <a:r>
-                        <a:rPr lang="en-US" sz="1050" dirty="0">
+                        <a:rPr lang="en-US" sz="1000" dirty="0">
                           <a:solidFill>
                             <a:srgbClr val="1F1F1F"/>
                           </a:solidFill>
@@ -7945,7 +7945,7 @@
                         </a:rPr>
                         <a:t>New year-indexed chart columns</a:t>
                       </a:r>
-                      <a:endParaRPr lang="en-US" sz="1050" dirty="0">
+                      <a:endParaRPr lang="en-US" sz="1000" dirty="0">
                         <a:latin typeface="Calibri" charset="0"/>
                         <a:ea typeface="Calibri" charset="0"/>
                         <a:cs typeface="Calibri" charset="0"/>
@@ -8003,7 +8003,7 @@
                         <a:buNone/>
                       </a:pPr>
                       <a:r>
-                        <a:rPr lang="en-US" sz="1050" dirty="0">
+                        <a:rPr lang="en-US" sz="1000" dirty="0">
                           <a:solidFill>
                             <a:srgbClr val="1F1F1F"/>
                           </a:solidFill>
@@ -8013,7 +8013,7 @@
                         </a:rPr>
                         <a:t>Direct plus lost revenue reconciles to activity totals; discounted column sums to NPW to the dollar</a:t>
                       </a:r>
-                      <a:endParaRPr lang="en-US" sz="1050" dirty="0">
+                      <a:endParaRPr lang="en-US" sz="1000" dirty="0">
                         <a:latin typeface="Calibri" charset="0"/>
                         <a:ea typeface="Calibri" charset="0"/>
                         <a:cs typeface="Calibri" charset="0"/>
@@ -8073,7 +8073,7 @@
                         <a:buNone/>
                       </a:pPr>
                       <a:r>
-                        <a:rPr lang="en-US" sz="1050" dirty="0">
+                        <a:rPr lang="en-US" sz="1000" dirty="0">
                           <a:solidFill>
                             <a:srgbClr val="1F1F1F"/>
                           </a:solidFill>
@@ -8081,9 +8081,9 @@
                           <a:ea typeface="Calibri" pitchFamily="34" charset="-122"/>
                           <a:cs typeface="Calibri" pitchFamily="34" charset="-120"/>
                         </a:rPr>
-                        <a:t>Patched chart XML</a:t>
+                        <a:t>Decision workbook, full recalculation</a:t>
                       </a:r>
-                      <a:endParaRPr lang="en-US" sz="1050" dirty="0">
+                      <a:endParaRPr lang="en-US" sz="1000" dirty="0">
                         <a:latin typeface="Calibri" charset="0"/>
                         <a:ea typeface="Calibri" charset="0"/>
                         <a:cs typeface="Calibri" charset="0"/>
@@ -8141,7 +8141,7 @@
                         <a:buNone/>
                       </a:pPr>
                       <a:r>
-                        <a:rPr lang="en-US" sz="1050" dirty="0">
+                        <a:rPr lang="en-US" sz="1000" dirty="0">
                           <a:solidFill>
                             <a:srgbClr val="1F1F1F"/>
                           </a:solidFill>
@@ -8149,9 +8149,9 @@
                           <a:ea typeface="Calibri" pitchFamily="34" charset="-122"/>
                           <a:cs typeface="Calibri" pitchFamily="34" charset="-120"/>
                         </a:rPr>
-                        <a:t>Well-formed; parsed by an independent chart reader with the intended year categories</a:t>
+                        <a:t>47,265 formulas, 0 errors</a:t>
                       </a:r>
-                      <a:endParaRPr lang="en-US" sz="1050" dirty="0">
+                      <a:endParaRPr lang="en-US" sz="1000" dirty="0">
                         <a:latin typeface="Calibri" charset="0"/>
                         <a:ea typeface="Calibri" charset="0"/>
                         <a:cs typeface="Calibri" charset="0"/>
@@ -8211,7 +8211,7 @@
                         <a:buNone/>
                       </a:pPr>
                       <a:r>
-                        <a:rPr lang="en-US" sz="1050" dirty="0">
+                        <a:rPr lang="en-US" sz="1000" dirty="0">
                           <a:solidFill>
                             <a:srgbClr val="1F1F1F"/>
                           </a:solidFill>
@@ -8219,9 +8219,9 @@
                           <a:ea typeface="Calibri" pitchFamily="34" charset="-122"/>
                           <a:cs typeface="Calibri" pitchFamily="34" charset="-120"/>
                         </a:rPr>
-                        <a:t>Decision workbook, full recalculation</a:t>
+                        <a:t>Decision workbook against an independent engine</a:t>
                       </a:r>
-                      <a:endParaRPr lang="en-US" sz="1050" dirty="0">
+                      <a:endParaRPr lang="en-US" sz="1000" dirty="0">
                         <a:latin typeface="Calibri" charset="0"/>
                         <a:ea typeface="Calibri" charset="0"/>
                         <a:cs typeface="Calibri" charset="0"/>
@@ -8279,7 +8279,7 @@
                         <a:buNone/>
                       </a:pPr>
                       <a:r>
-                        <a:rPr lang="en-US" sz="1050" dirty="0">
+                        <a:rPr lang="en-US" sz="1000" dirty="0">
                           <a:solidFill>
                             <a:srgbClr val="1F1F1F"/>
                           </a:solidFill>
@@ -8287,9 +8287,9 @@
                           <a:ea typeface="Calibri" pitchFamily="34" charset="-122"/>
                           <a:cs typeface="Calibri" pitchFamily="34" charset="-120"/>
                         </a:rPr>
-                        <a:t>47,265 formulas, 0 errors</a:t>
+                        <a:t>NPW, categories, break-evens, sensitivity, tornado, 12 scenarios and the decision map agree to the dollar</a:t>
                       </a:r>
-                      <a:endParaRPr lang="en-US" sz="1050" dirty="0">
+                      <a:endParaRPr lang="en-US" sz="1000" dirty="0">
                         <a:latin typeface="Calibri" charset="0"/>
                         <a:ea typeface="Calibri" charset="0"/>
                         <a:cs typeface="Calibri" charset="0"/>
@@ -8349,7 +8349,7 @@
                         <a:buNone/>
                       </a:pPr>
                       <a:r>
-                        <a:rPr lang="en-US" sz="1050" dirty="0">
+                        <a:rPr lang="en-US" sz="1000" dirty="0">
                           <a:solidFill>
                             <a:srgbClr val="1F1F1F"/>
                           </a:solidFill>
@@ -8357,9 +8357,9 @@
                           <a:ea typeface="Calibri" pitchFamily="34" charset="-122"/>
                           <a:cs typeface="Calibri" pitchFamily="34" charset="-120"/>
                         </a:rPr>
-                        <a:t>Decision workbook against an independent engine</a:t>
+                        <a:t>New Summary sheet on the MBT data</a:t>
                       </a:r>
-                      <a:endParaRPr lang="en-US" sz="1050" dirty="0">
+                      <a:endParaRPr lang="en-US" sz="1000" dirty="0">
                         <a:latin typeface="Calibri" charset="0"/>
                         <a:ea typeface="Calibri" charset="0"/>
                         <a:cs typeface="Calibri" charset="0"/>
@@ -8417,7 +8417,7 @@
                         <a:buNone/>
                       </a:pPr>
                       <a:r>
-                        <a:rPr lang="en-US" sz="1050" dirty="0">
+                        <a:rPr lang="en-US" sz="1000" dirty="0">
                           <a:solidFill>
                             <a:srgbClr val="1F1F1F"/>
                           </a:solidFill>
@@ -8425,9 +8425,9 @@
                           <a:ea typeface="Calibri" pitchFamily="34" charset="-122"/>
                           <a:cs typeface="Calibri" pitchFamily="34" charset="-120"/>
                         </a:rPr>
-                        <a:t>NPW, categories, break-evens, sensitivity, tornado, 12 scenarios and the decision map agree to the dollar</a:t>
+                        <a:t>Table, verdict, categories and closure days match; six charts render; template reads "No alternatives yet" with no errors</a:t>
                       </a:r>
-                      <a:endParaRPr lang="en-US" sz="1050" dirty="0">
+                      <a:endParaRPr lang="en-US" sz="1000" dirty="0">
                         <a:latin typeface="Calibri" charset="0"/>
                         <a:ea typeface="Calibri" charset="0"/>
                         <a:cs typeface="Calibri" charset="0"/>
@@ -8487,7 +8487,7 @@
                         <a:buNone/>
                       </a:pPr>
                       <a:r>
-                        <a:rPr lang="en-US" sz="1050" dirty="0">
+                        <a:rPr lang="en-US" sz="1000" dirty="0">
                           <a:solidFill>
                             <a:srgbClr val="1F1F1F"/>
                           </a:solidFill>
@@ -8495,9 +8495,9 @@
                           <a:ea typeface="Calibri" pitchFamily="34" charset="-122"/>
                           <a:cs typeface="Calibri" pitchFamily="34" charset="-120"/>
                         </a:rPr>
-                        <a:t>Charts rendered to PDF</a:t>
+                        <a:t>Scripted click-through (LibreOffice API)</a:t>
                       </a:r>
-                      <a:endParaRPr lang="en-US" sz="1050" dirty="0">
+                      <a:endParaRPr lang="en-US" sz="1000" dirty="0">
                         <a:latin typeface="Calibri" charset="0"/>
                         <a:ea typeface="Calibri" charset="0"/>
                         <a:cs typeface="Calibri" charset="0"/>
@@ -8555,7 +8555,7 @@
                         <a:buNone/>
                       </a:pPr>
                       <a:r>
-                        <a:rPr lang="en-US" sz="1050" dirty="0">
+                        <a:rPr lang="en-US" sz="1000" dirty="0">
                           <a:solidFill>
                             <a:srgbClr val="1F1F1F"/>
                           </a:solidFill>
@@ -8563,9 +8563,9 @@
                           <a:ea typeface="Calibri" pitchFamily="34" charset="-122"/>
                           <a:cs typeface="Calibri" pitchFamily="34" charset="-120"/>
                         </a:rPr>
-                        <a:t>All eight per-project charts and the simulation histogram draw correctly</a:t>
+                        <a:t>Buttons land where they should; 7% flips the verdict as flagged; 20 years drops late closures; unknown airport gives $0 lost revenue with a warning, no errors</a:t>
                       </a:r>
-                      <a:endParaRPr lang="en-US" sz="1050" dirty="0">
+                      <a:endParaRPr lang="en-US" sz="1000" dirty="0">
                         <a:latin typeface="Calibri" charset="0"/>
                         <a:ea typeface="Calibri" charset="0"/>
                         <a:cs typeface="Calibri" charset="0"/>
@@ -8625,7 +8625,7 @@
                         <a:buNone/>
                       </a:pPr>
                       <a:r>
-                        <a:rPr lang="en-US" sz="1050" dirty="0">
+                        <a:rPr lang="en-US" sz="1000" dirty="0">
                           <a:solidFill>
                             <a:srgbClr val="1F1F1F"/>
                           </a:solidFill>
@@ -8633,9 +8633,9 @@
                           <a:ea typeface="Calibri" pitchFamily="34" charset="-122"/>
                           <a:cs typeface="Calibri" pitchFamily="34" charset="-120"/>
                         </a:rPr>
-                        <a:t>New Summary sheet on the MBT data</a:t>
+                        <a:t>Not yet verified</a:t>
                       </a:r>
-                      <a:endParaRPr lang="en-US" sz="1050" dirty="0">
+                      <a:endParaRPr lang="en-US" sz="1000" dirty="0">
                         <a:latin typeface="Calibri" charset="0"/>
                         <a:ea typeface="Calibri" charset="0"/>
                         <a:cs typeface="Calibri" charset="0"/>
@@ -8693,145 +8693,7 @@
                         <a:buNone/>
                       </a:pPr>
                       <a:r>
-                        <a:rPr lang="en-US" sz="1050" dirty="0">
-                          <a:solidFill>
-                            <a:srgbClr val="1F1F1F"/>
-                          </a:solidFill>
-                          <a:latin typeface="Calibri" pitchFamily="34" charset="0"/>
-                          <a:ea typeface="Calibri" pitchFamily="34" charset="-122"/>
-                          <a:cs typeface="Calibri" pitchFamily="34" charset="-120"/>
-                        </a:rPr>
-                        <a:t>Table, verdict, categories and closure days match; six charts render; template reads "No alternatives yet" with no errors</a:t>
-                      </a:r>
-                      <a:endParaRPr lang="en-US" sz="1050" dirty="0">
-                        <a:latin typeface="Calibri" charset="0"/>
-                        <a:ea typeface="Calibri" charset="0"/>
-                        <a:cs typeface="Calibri" charset="0"/>
-                      </a:endParaRPr>
-                    </a:p>
-                  </a:txBody>
-                  <a:tcPr marL="45720" marR="45720" marT="45720" marB="45720" anchor="ctr">
-                    <a:lnL w="6350" cap="flat" cmpd="sng" algn="ctr">
-                      <a:solidFill>
-                        <a:srgbClr val="C9C9C4"/>
-                      </a:solidFill>
-                      <a:prstDash val="solid"/>
-                      <a:round/>
-                      <a:headEnd type="none" w="med" len="med"/>
-                      <a:tailEnd type="none" w="med" len="med"/>
-                    </a:lnL>
-                    <a:lnR w="6350" cap="flat" cmpd="sng" algn="ctr">
-                      <a:solidFill>
-                        <a:srgbClr val="C9C9C4"/>
-                      </a:solidFill>
-                      <a:prstDash val="solid"/>
-                      <a:round/>
-                      <a:headEnd type="none" w="med" len="med"/>
-                      <a:tailEnd type="none" w="med" len="med"/>
-                    </a:lnR>
-                    <a:lnT w="6350" cap="flat" cmpd="sng" algn="ctr">
-                      <a:solidFill>
-                        <a:srgbClr val="C9C9C4"/>
-                      </a:solidFill>
-                      <a:prstDash val="solid"/>
-                      <a:round/>
-                      <a:headEnd type="none" w="med" len="med"/>
-                      <a:tailEnd type="none" w="med" len="med"/>
-                    </a:lnT>
-                    <a:lnB w="6350" cap="flat" cmpd="sng" algn="ctr">
-                      <a:solidFill>
-                        <a:srgbClr val="C9C9C4"/>
-                      </a:solidFill>
-                      <a:prstDash val="solid"/>
-                      <a:round/>
-                      <a:headEnd type="none" w="med" len="med"/>
-                      <a:tailEnd type="none" w="med" len="med"/>
-                    </a:lnB>
-                    <a:solidFill>
-                      <a:srgbClr val="FFFFFF"/>
-                    </a:solidFill>
-                  </a:tcPr>
-                </a:tc>
-              </a:tr>
-              <a:tr h="274320">
-                <a:tc>
-                  <a:txBody>
-                    <a:bodyPr/>
-                    <a:lstStyle/>
-                    <a:p>
-                      <a:pPr indent="0" marL="0">
-                        <a:buNone/>
-                      </a:pPr>
-                      <a:r>
-                        <a:rPr lang="en-US" sz="1050" dirty="0">
-                          <a:solidFill>
-                            <a:srgbClr val="1F1F1F"/>
-                          </a:solidFill>
-                          <a:latin typeface="Calibri" pitchFamily="34" charset="0"/>
-                          <a:ea typeface="Calibri" pitchFamily="34" charset="-122"/>
-                          <a:cs typeface="Calibri" pitchFamily="34" charset="-120"/>
-                        </a:rPr>
-                        <a:t>Not yet verified</a:t>
-                      </a:r>
-                      <a:endParaRPr lang="en-US" sz="1050" dirty="0">
-                        <a:latin typeface="Calibri" charset="0"/>
-                        <a:ea typeface="Calibri" charset="0"/>
-                        <a:cs typeface="Calibri" charset="0"/>
-                      </a:endParaRPr>
-                    </a:p>
-                  </a:txBody>
-                  <a:tcPr marL="45720" marR="45720" marT="45720" marB="45720" anchor="ctr">
-                    <a:lnL w="6350" cap="flat" cmpd="sng" algn="ctr">
-                      <a:solidFill>
-                        <a:srgbClr val="C9C9C4"/>
-                      </a:solidFill>
-                      <a:prstDash val="solid"/>
-                      <a:round/>
-                      <a:headEnd type="none" w="med" len="med"/>
-                      <a:tailEnd type="none" w="med" len="med"/>
-                    </a:lnL>
-                    <a:lnR w="6350" cap="flat" cmpd="sng" algn="ctr">
-                      <a:solidFill>
-                        <a:srgbClr val="C9C9C4"/>
-                      </a:solidFill>
-                      <a:prstDash val="solid"/>
-                      <a:round/>
-                      <a:headEnd type="none" w="med" len="med"/>
-                      <a:tailEnd type="none" w="med" len="med"/>
-                    </a:lnR>
-                    <a:lnT w="6350" cap="flat" cmpd="sng" algn="ctr">
-                      <a:solidFill>
-                        <a:srgbClr val="C9C9C4"/>
-                      </a:solidFill>
-                      <a:prstDash val="solid"/>
-                      <a:round/>
-                      <a:headEnd type="none" w="med" len="med"/>
-                      <a:tailEnd type="none" w="med" len="med"/>
-                    </a:lnT>
-                    <a:lnB w="6350" cap="flat" cmpd="sng" algn="ctr">
-                      <a:solidFill>
-                        <a:srgbClr val="C9C9C4"/>
-                      </a:solidFill>
-                      <a:prstDash val="solid"/>
-                      <a:round/>
-                      <a:headEnd type="none" w="med" len="med"/>
-                      <a:tailEnd type="none" w="med" len="med"/>
-                    </a:lnB>
-                    <a:solidFill>
-                      <a:srgbClr val="FFFFFF"/>
-                    </a:solidFill>
-                  </a:tcPr>
-                </a:tc>
-                <a:tc>
-                  <a:txBody>
-                    <a:bodyPr/>
-                    <a:lstStyle/>
-                    <a:p>
-                      <a:pPr indent="0" marL="0">
-                        <a:buNone/>
-                      </a:pPr>
-                      <a:r>
-                        <a:rPr lang="en-US" sz="1050" dirty="0">
+                        <a:rPr lang="en-US" sz="1000" dirty="0">
                           <a:solidFill>
                             <a:srgbClr val="1F1F1F"/>
                           </a:solidFill>
@@ -8841,7 +8703,7 @@
                         </a:rPr>
                         <a:t>The alternative-sheet charts in Excel itself (no Excel here); a first-open check is in the notes</a:t>
                       </a:r>
-                      <a:endParaRPr lang="en-US" sz="1050" dirty="0">
+                      <a:endParaRPr lang="en-US" sz="1000" dirty="0">
                         <a:latin typeface="Calibri" charset="0"/>
                         <a:ea typeface="Calibri" charset="0"/>
                         <a:cs typeface="Calibri" charset="0"/>

</xml_diff>

<commit_message>
Package hygiene, plain-text sources and the shoulder section string
Drop the six cached printer-settings parts, the empty Power Query stub and the
cached SharePoint path from the workbook package; document properties now name
the organisation. Typical Values sources are plain text. The Summary section
block gains a column Q that reads the section over mainline plus shoulder when
a shoulder area is entered. Change notes, report, deck and a parametrised
two-example runner (GKT three alternatives, MKL four with shoulders) added.

Co-Authored-By: Claude Fable 5.1 <noreply@anthropic.com>
Claude-Session: https://claude.ai/code/session_01JrCXNd278qC95SDvCCWbYM
</commit_message>
<xml_diff>
--- a/tdot-lcca/TDOT_LCCA_Review_and_v1.2.0_Update.pptx
+++ b/tdot-lcca/TDOT_LCCA_Review_and_v1.2.0_Update.pptx
@@ -4049,7 +4049,7 @@
                           <a:ea typeface="Calibri" pitchFamily="34" charset="-122"/>
                           <a:cs typeface="Calibri" pitchFamily="34" charset="-120"/>
                         </a:rPr>
-                        <a:t>Personal names removed from cell notes; two dead links to files on a C: drive removed; full recalculation on open</a:t>
+                        <a:t>Personal names removed from cell notes and document properties; dead links, cached printer settings, Power Query stub and SharePoint path removed; sources on Typical Values as plain text; full recalculation on open</a:t>
                       </a:r>
                       <a:endParaRPr lang="en-US" sz="1050" dirty="0">
                         <a:latin typeface="Calibri" charset="0"/>
@@ -9608,6 +9608,144 @@
                           <a:cs typeface="Calibri" pitchFamily="34" charset="-120"/>
                         </a:rPr>
                         <a:t>CKV Runway 17-35 built on the blank template: framework, decision TEMPLATE and an independent engine agree to the dollar</a:t>
+                      </a:r>
+                      <a:endParaRPr lang="en-US" sz="1000" dirty="0">
+                        <a:latin typeface="Calibri" charset="0"/>
+                        <a:ea typeface="Calibri" charset="0"/>
+                        <a:cs typeface="Calibri" charset="0"/>
+                      </a:endParaRPr>
+                    </a:p>
+                  </a:txBody>
+                  <a:tcPr marL="45720" marR="45720" marT="45720" marB="45720" anchor="ctr">
+                    <a:lnL w="6350" cap="flat" cmpd="sng" algn="ctr">
+                      <a:solidFill>
+                        <a:srgbClr val="C9C9C4"/>
+                      </a:solidFill>
+                      <a:prstDash val="solid"/>
+                      <a:round/>
+                      <a:headEnd type="none" w="med" len="med"/>
+                      <a:tailEnd type="none" w="med" len="med"/>
+                    </a:lnL>
+                    <a:lnR w="6350" cap="flat" cmpd="sng" algn="ctr">
+                      <a:solidFill>
+                        <a:srgbClr val="C9C9C4"/>
+                      </a:solidFill>
+                      <a:prstDash val="solid"/>
+                      <a:round/>
+                      <a:headEnd type="none" w="med" len="med"/>
+                      <a:tailEnd type="none" w="med" len="med"/>
+                    </a:lnR>
+                    <a:lnT w="6350" cap="flat" cmpd="sng" algn="ctr">
+                      <a:solidFill>
+                        <a:srgbClr val="C9C9C4"/>
+                      </a:solidFill>
+                      <a:prstDash val="solid"/>
+                      <a:round/>
+                      <a:headEnd type="none" w="med" len="med"/>
+                      <a:tailEnd type="none" w="med" len="med"/>
+                    </a:lnT>
+                    <a:lnB w="6350" cap="flat" cmpd="sng" algn="ctr">
+                      <a:solidFill>
+                        <a:srgbClr val="C9C9C4"/>
+                      </a:solidFill>
+                      <a:prstDash val="solid"/>
+                      <a:round/>
+                      <a:headEnd type="none" w="med" len="med"/>
+                      <a:tailEnd type="none" w="med" len="med"/>
+                    </a:lnB>
+                    <a:solidFill>
+                      <a:srgbClr val="FFFFFF"/>
+                    </a:solidFill>
+                  </a:tcPr>
+                </a:tc>
+              </a:tr>
+              <a:tr h="274320">
+                <a:tc>
+                  <a:txBody>
+                    <a:bodyPr/>
+                    <a:lstStyle/>
+                    <a:p>
+                      <a:pPr indent="0" marL="0">
+                        <a:buNone/>
+                      </a:pPr>
+                      <a:r>
+                        <a:rPr lang="en-US" sz="1000" dirty="0">
+                          <a:solidFill>
+                            <a:srgbClr val="1F1F1F"/>
+                          </a:solidFill>
+                          <a:latin typeface="Calibri" pitchFamily="34" charset="0"/>
+                          <a:ea typeface="Calibri" pitchFamily="34" charset="-122"/>
+                          <a:cs typeface="Calibri" pitchFamily="34" charset="-120"/>
+                        </a:rPr>
+                        <a:t>Two worked examples</a:t>
+                      </a:r>
+                      <a:endParaRPr lang="en-US" sz="1000" dirty="0">
+                        <a:latin typeface="Calibri" charset="0"/>
+                        <a:ea typeface="Calibri" charset="0"/>
+                        <a:cs typeface="Calibri" charset="0"/>
+                      </a:endParaRPr>
+                    </a:p>
+                  </a:txBody>
+                  <a:tcPr marL="45720" marR="45720" marT="45720" marB="45720" anchor="ctr">
+                    <a:lnL w="6350" cap="flat" cmpd="sng" algn="ctr">
+                      <a:solidFill>
+                        <a:srgbClr val="C9C9C4"/>
+                      </a:solidFill>
+                      <a:prstDash val="solid"/>
+                      <a:round/>
+                      <a:headEnd type="none" w="med" len="med"/>
+                      <a:tailEnd type="none" w="med" len="med"/>
+                    </a:lnL>
+                    <a:lnR w="6350" cap="flat" cmpd="sng" algn="ctr">
+                      <a:solidFill>
+                        <a:srgbClr val="C9C9C4"/>
+                      </a:solidFill>
+                      <a:prstDash val="solid"/>
+                      <a:round/>
+                      <a:headEnd type="none" w="med" len="med"/>
+                      <a:tailEnd type="none" w="med" len="med"/>
+                    </a:lnR>
+                    <a:lnT w="6350" cap="flat" cmpd="sng" algn="ctr">
+                      <a:solidFill>
+                        <a:srgbClr val="C9C9C4"/>
+                      </a:solidFill>
+                      <a:prstDash val="solid"/>
+                      <a:round/>
+                      <a:headEnd type="none" w="med" len="med"/>
+                      <a:tailEnd type="none" w="med" len="med"/>
+                    </a:lnT>
+                    <a:lnB w="6350" cap="flat" cmpd="sng" algn="ctr">
+                      <a:solidFill>
+                        <a:srgbClr val="C9C9C4"/>
+                      </a:solidFill>
+                      <a:prstDash val="solid"/>
+                      <a:round/>
+                      <a:headEnd type="none" w="med" len="med"/>
+                      <a:tailEnd type="none" w="med" len="med"/>
+                    </a:lnB>
+                    <a:solidFill>
+                      <a:srgbClr val="FFFFFF"/>
+                    </a:solidFill>
+                  </a:tcPr>
+                </a:tc>
+                <a:tc>
+                  <a:txBody>
+                    <a:bodyPr/>
+                    <a:lstStyle/>
+                    <a:p>
+                      <a:pPr indent="0" marL="0">
+                        <a:buNone/>
+                      </a:pPr>
+                      <a:r>
+                        <a:rPr lang="en-US" sz="1000" dirty="0">
+                          <a:solidFill>
+                            <a:srgbClr val="1F1F1F"/>
+                          </a:solidFill>
+                          <a:latin typeface="Calibri" pitchFamily="34" charset="0"/>
+                          <a:ea typeface="Calibri" pitchFamily="34" charset="-122"/>
+                          <a:cs typeface="Calibri" pitchFamily="34" charset="-120"/>
+                        </a:rPr>
+                        <a:t>GKT Runway 10-28 (three alternatives, no shoulders) and MKL Runway 2-20 (four alternatives, 25 ft shoulders): 99 independent checks pass; section read-back returns the designed sections</a:t>
                       </a:r>
                       <a:endParaRPr lang="en-US" sz="1000" dirty="0">
                         <a:latin typeface="Calibri" charset="0"/>

</xml_diff>

<commit_message>
Add a Method sheet that records every calculation, its rule and its source
New reference sheet (last, nothing feeds the calculation): each step with the
cell it lives in, the formula as it stands there, the rule in plain English and
where the rule comes from; a live block reading the current period, rate and
capital recovery factor; and the assumptions a reviewer will ask about. Button
on General Information D48. Notes, report and deck updated.

Recalculation 2,524 formulas 0 errors; click-through 50 checks pass; the MKL
four-alternative example re-run passes all 61 checks.

Co-Authored-By: Claude Opus 5 <noreply@anthropic.com>
Claude-Session: https://claude.ai/code/session_01JrCXNd278qC95SDvCCWbYM
</commit_message>
<xml_diff>
--- a/tdot-lcca/TDOT_LCCA_Review_and_v1.2.0_Update.pptx
+++ b/tdot-lcca/TDOT_LCCA_Review_and_v1.2.0_Update.pptx
@@ -3843,6 +3843,144 @@
                           <a:ea typeface="Calibri" pitchFamily="34" charset="-122"/>
                           <a:cs typeface="Calibri" pitchFamily="34" charset="-120"/>
                         </a:rPr>
+                        <a:t>Method sheet</a:t>
+                      </a:r>
+                      <a:endParaRPr lang="en-US" sz="1050" dirty="0">
+                        <a:latin typeface="Calibri" charset="0"/>
+                        <a:ea typeface="Calibri" charset="0"/>
+                        <a:cs typeface="Calibri" charset="0"/>
+                      </a:endParaRPr>
+                    </a:p>
+                  </a:txBody>
+                  <a:tcPr marL="45720" marR="45720" marT="45720" marB="45720" anchor="ctr">
+                    <a:lnL w="6350" cap="flat" cmpd="sng" algn="ctr">
+                      <a:solidFill>
+                        <a:srgbClr val="C9C9C4"/>
+                      </a:solidFill>
+                      <a:prstDash val="solid"/>
+                      <a:round/>
+                      <a:headEnd type="none" w="med" len="med"/>
+                      <a:tailEnd type="none" w="med" len="med"/>
+                    </a:lnL>
+                    <a:lnR w="6350" cap="flat" cmpd="sng" algn="ctr">
+                      <a:solidFill>
+                        <a:srgbClr val="C9C9C4"/>
+                      </a:solidFill>
+                      <a:prstDash val="solid"/>
+                      <a:round/>
+                      <a:headEnd type="none" w="med" len="med"/>
+                      <a:tailEnd type="none" w="med" len="med"/>
+                    </a:lnR>
+                    <a:lnT w="6350" cap="flat" cmpd="sng" algn="ctr">
+                      <a:solidFill>
+                        <a:srgbClr val="C9C9C4"/>
+                      </a:solidFill>
+                      <a:prstDash val="solid"/>
+                      <a:round/>
+                      <a:headEnd type="none" w="med" len="med"/>
+                      <a:tailEnd type="none" w="med" len="med"/>
+                    </a:lnT>
+                    <a:lnB w="6350" cap="flat" cmpd="sng" algn="ctr">
+                      <a:solidFill>
+                        <a:srgbClr val="C9C9C4"/>
+                      </a:solidFill>
+                      <a:prstDash val="solid"/>
+                      <a:round/>
+                      <a:headEnd type="none" w="med" len="med"/>
+                      <a:tailEnd type="none" w="med" len="med"/>
+                    </a:lnB>
+                    <a:solidFill>
+                      <a:srgbClr val="FFFFFF"/>
+                    </a:solidFill>
+                  </a:tcPr>
+                </a:tc>
+                <a:tc>
+                  <a:txBody>
+                    <a:bodyPr/>
+                    <a:lstStyle/>
+                    <a:p>
+                      <a:pPr indent="0" marL="0">
+                        <a:buNone/>
+                      </a:pPr>
+                      <a:r>
+                        <a:rPr lang="en-US" sz="1050" dirty="0">
+                          <a:solidFill>
+                            <a:srgbClr val="1F1F1F"/>
+                          </a:solidFill>
+                          <a:latin typeface="Calibri" pitchFamily="34" charset="0"/>
+                          <a:ea typeface="Calibri" pitchFamily="34" charset="-122"/>
+                          <a:cs typeface="Calibri" pitchFamily="34" charset="-120"/>
+                        </a:rPr>
+                        <a:t>New reference sheet: every calculation once, with the formula, the rule in plain English and its source; a live block reading the current rate, period and capital recovery factor; and the assumptions a reviewer will ask about</a:t>
+                      </a:r>
+                      <a:endParaRPr lang="en-US" sz="1050" dirty="0">
+                        <a:latin typeface="Calibri" charset="0"/>
+                        <a:ea typeface="Calibri" charset="0"/>
+                        <a:cs typeface="Calibri" charset="0"/>
+                      </a:endParaRPr>
+                    </a:p>
+                  </a:txBody>
+                  <a:tcPr marL="45720" marR="45720" marT="45720" marB="45720" anchor="ctr">
+                    <a:lnL w="6350" cap="flat" cmpd="sng" algn="ctr">
+                      <a:solidFill>
+                        <a:srgbClr val="C9C9C4"/>
+                      </a:solidFill>
+                      <a:prstDash val="solid"/>
+                      <a:round/>
+                      <a:headEnd type="none" w="med" len="med"/>
+                      <a:tailEnd type="none" w="med" len="med"/>
+                    </a:lnL>
+                    <a:lnR w="6350" cap="flat" cmpd="sng" algn="ctr">
+                      <a:solidFill>
+                        <a:srgbClr val="C9C9C4"/>
+                      </a:solidFill>
+                      <a:prstDash val="solid"/>
+                      <a:round/>
+                      <a:headEnd type="none" w="med" len="med"/>
+                      <a:tailEnd type="none" w="med" len="med"/>
+                    </a:lnR>
+                    <a:lnT w="6350" cap="flat" cmpd="sng" algn="ctr">
+                      <a:solidFill>
+                        <a:srgbClr val="C9C9C4"/>
+                      </a:solidFill>
+                      <a:prstDash val="solid"/>
+                      <a:round/>
+                      <a:headEnd type="none" w="med" len="med"/>
+                      <a:tailEnd type="none" w="med" len="med"/>
+                    </a:lnT>
+                    <a:lnB w="6350" cap="flat" cmpd="sng" algn="ctr">
+                      <a:solidFill>
+                        <a:srgbClr val="C9C9C4"/>
+                      </a:solidFill>
+                      <a:prstDash val="solid"/>
+                      <a:round/>
+                      <a:headEnd type="none" w="med" len="med"/>
+                      <a:tailEnd type="none" w="med" len="med"/>
+                    </a:lnB>
+                    <a:solidFill>
+                      <a:srgbClr val="FFFFFF"/>
+                    </a:solidFill>
+                  </a:tcPr>
+                </a:tc>
+              </a:tr>
+              <a:tr h="274320">
+                <a:tc>
+                  <a:txBody>
+                    <a:bodyPr/>
+                    <a:lstStyle/>
+                    <a:p>
+                      <a:pPr indent="0" marL="0">
+                        <a:buNone/>
+                      </a:pPr>
+                      <a:r>
+                        <a:rPr lang="en-US" sz="1050" dirty="0">
+                          <a:solidFill>
+                            <a:srgbClr val="1F1F1F"/>
+                          </a:solidFill>
+                          <a:latin typeface="Calibri" pitchFamily="34" charset="0"/>
+                          <a:ea typeface="Calibri" pitchFamily="34" charset="-122"/>
+                          <a:cs typeface="Calibri" pitchFamily="34" charset="-120"/>
+                        </a:rPr>
                         <a:t>Typical Values sheet</a:t>
                       </a:r>
                       <a:endParaRPr lang="en-US" sz="1050" dirty="0">

</xml_diff>

<commit_message>
Name the x and y axis on every chart in both workbooks
The five original alternative-sheet charts and the original Alternatives
Comparison chart get axis titles injected into their chart XML; the seven
Summary charts and all 27 decision-workbook charts get them from the builders.
Also a test copy of the framework whose pay-item dropdown lists descriptions
only, so the full text is readable.

Recalculation clean: framework 2,524 formulas, decision workbook 47,331, no
errors.

Co-Authored-By: Claude Opus 5 <noreply@anthropic.com>
Claude-Session: https://claude.ai/code/session_01JrCXNd278qC95SDvCCWbYM
</commit_message>
<xml_diff>
--- a/tdot-lcca/TDOT_LCCA_Review_and_v1.2.0_Update.pptx
+++ b/tdot-lcca/TDOT_LCCA_Review_and_v1.2.0_Update.pptx
@@ -3429,6 +3429,144 @@
                           <a:ea typeface="Calibri" pitchFamily="34" charset="-122"/>
                           <a:cs typeface="Calibri" pitchFamily="34" charset="-120"/>
                         </a:rPr>
+                        <a:t>Chart axes</a:t>
+                      </a:r>
+                      <a:endParaRPr lang="en-US" sz="1050" dirty="0">
+                        <a:latin typeface="Calibri" charset="0"/>
+                        <a:ea typeface="Calibri" charset="0"/>
+                        <a:cs typeface="Calibri" charset="0"/>
+                      </a:endParaRPr>
+                    </a:p>
+                  </a:txBody>
+                  <a:tcPr marL="45720" marR="45720" marT="45720" marB="45720" anchor="ctr">
+                    <a:lnL w="6350" cap="flat" cmpd="sng" algn="ctr">
+                      <a:solidFill>
+                        <a:srgbClr val="C9C9C4"/>
+                      </a:solidFill>
+                      <a:prstDash val="solid"/>
+                      <a:round/>
+                      <a:headEnd type="none" w="med" len="med"/>
+                      <a:tailEnd type="none" w="med" len="med"/>
+                    </a:lnL>
+                    <a:lnR w="6350" cap="flat" cmpd="sng" algn="ctr">
+                      <a:solidFill>
+                        <a:srgbClr val="C9C9C4"/>
+                      </a:solidFill>
+                      <a:prstDash val="solid"/>
+                      <a:round/>
+                      <a:headEnd type="none" w="med" len="med"/>
+                      <a:tailEnd type="none" w="med" len="med"/>
+                    </a:lnR>
+                    <a:lnT w="6350" cap="flat" cmpd="sng" algn="ctr">
+                      <a:solidFill>
+                        <a:srgbClr val="C9C9C4"/>
+                      </a:solidFill>
+                      <a:prstDash val="solid"/>
+                      <a:round/>
+                      <a:headEnd type="none" w="med" len="med"/>
+                      <a:tailEnd type="none" w="med" len="med"/>
+                    </a:lnT>
+                    <a:lnB w="6350" cap="flat" cmpd="sng" algn="ctr">
+                      <a:solidFill>
+                        <a:srgbClr val="C9C9C4"/>
+                      </a:solidFill>
+                      <a:prstDash val="solid"/>
+                      <a:round/>
+                      <a:headEnd type="none" w="med" len="med"/>
+                      <a:tailEnd type="none" w="med" len="med"/>
+                    </a:lnB>
+                    <a:solidFill>
+                      <a:srgbClr val="FFFFFF"/>
+                    </a:solidFill>
+                  </a:tcPr>
+                </a:tc>
+                <a:tc>
+                  <a:txBody>
+                    <a:bodyPr/>
+                    <a:lstStyle/>
+                    <a:p>
+                      <a:pPr indent="0" marL="0">
+                        <a:buNone/>
+                      </a:pPr>
+                      <a:r>
+                        <a:rPr lang="en-US" sz="1050" dirty="0">
+                          <a:solidFill>
+                            <a:srgbClr val="1F1F1F"/>
+                          </a:solidFill>
+                          <a:latin typeface="Calibri" pitchFamily="34" charset="0"/>
+                          <a:ea typeface="Calibri" pitchFamily="34" charset="-122"/>
+                          <a:cs typeface="Calibri" pitchFamily="34" charset="-120"/>
+                        </a:rPr>
+                        <a:t>Every chart in both workbooks now names its x and y axis</a:t>
+                      </a:r>
+                      <a:endParaRPr lang="en-US" sz="1050" dirty="0">
+                        <a:latin typeface="Calibri" charset="0"/>
+                        <a:ea typeface="Calibri" charset="0"/>
+                        <a:cs typeface="Calibri" charset="0"/>
+                      </a:endParaRPr>
+                    </a:p>
+                  </a:txBody>
+                  <a:tcPr marL="45720" marR="45720" marT="45720" marB="45720" anchor="ctr">
+                    <a:lnL w="6350" cap="flat" cmpd="sng" algn="ctr">
+                      <a:solidFill>
+                        <a:srgbClr val="C9C9C4"/>
+                      </a:solidFill>
+                      <a:prstDash val="solid"/>
+                      <a:round/>
+                      <a:headEnd type="none" w="med" len="med"/>
+                      <a:tailEnd type="none" w="med" len="med"/>
+                    </a:lnL>
+                    <a:lnR w="6350" cap="flat" cmpd="sng" algn="ctr">
+                      <a:solidFill>
+                        <a:srgbClr val="C9C9C4"/>
+                      </a:solidFill>
+                      <a:prstDash val="solid"/>
+                      <a:round/>
+                      <a:headEnd type="none" w="med" len="med"/>
+                      <a:tailEnd type="none" w="med" len="med"/>
+                    </a:lnR>
+                    <a:lnT w="6350" cap="flat" cmpd="sng" algn="ctr">
+                      <a:solidFill>
+                        <a:srgbClr val="C9C9C4"/>
+                      </a:solidFill>
+                      <a:prstDash val="solid"/>
+                      <a:round/>
+                      <a:headEnd type="none" w="med" len="med"/>
+                      <a:tailEnd type="none" w="med" len="med"/>
+                    </a:lnT>
+                    <a:lnB w="6350" cap="flat" cmpd="sng" algn="ctr">
+                      <a:solidFill>
+                        <a:srgbClr val="C9C9C4"/>
+                      </a:solidFill>
+                      <a:prstDash val="solid"/>
+                      <a:round/>
+                      <a:headEnd type="none" w="med" len="med"/>
+                      <a:tailEnd type="none" w="med" len="med"/>
+                    </a:lnB>
+                    <a:solidFill>
+                      <a:srgbClr val="FFFFFF"/>
+                    </a:solidFill>
+                  </a:tcPr>
+                </a:tc>
+              </a:tr>
+              <a:tr h="274320">
+                <a:tc>
+                  <a:txBody>
+                    <a:bodyPr/>
+                    <a:lstStyle/>
+                    <a:p>
+                      <a:pPr indent="0" marL="0">
+                        <a:buNone/>
+                      </a:pPr>
+                      <a:r>
+                        <a:rPr lang="en-US" sz="1050" dirty="0">
+                          <a:solidFill>
+                            <a:srgbClr val="1F1F1F"/>
+                          </a:solidFill>
+                          <a:latin typeface="Calibri" pitchFamily="34" charset="0"/>
+                          <a:ea typeface="Calibri" pitchFamily="34" charset="-122"/>
+                          <a:cs typeface="Calibri" pitchFamily="34" charset="-120"/>
+                        </a:rPr>
                         <a:t>Summary sheet</a:t>
                       </a:r>
                       <a:endParaRPr lang="en-US" sz="1050" dirty="0">

</xml_diff>

<commit_message>
Realign the Summary: hide the duplicate left table, move legends off the labels
Columns A to F (the block the Alternative Setup form writes) are hidden, so the
results table and the seven charts start at the left edge; the navigation
buttons move to G1 and H1 and the original Alternatives Comparison chart is set
to plot hidden cells and reads in millions. Chart legends move to the right of
each plot, money axes gain a decimal, and an alternative that does not exist is
no longer named on an axis or in a legend.

Recalculation 2,524 formulas 0 errors; the four-alternative example re-runs with
all 61 checks passing.

Co-Authored-By: Claude Opus 5 <noreply@anthropic.com>
Claude-Session: https://claude.ai/code/session_01JrCXNd278qC95SDvCCWbYM
</commit_message>
<xml_diff>
--- a/tdot-lcca/TDOT_LCCA_Review_and_v1.2.0_Update.pptx
+++ b/tdot-lcca/TDOT_LCCA_Review_and_v1.2.0_Update.pptx
@@ -3497,7 +3497,145 @@
                           <a:ea typeface="Calibri" pitchFamily="34" charset="-122"/>
                           <a:cs typeface="Calibri" pitchFamily="34" charset="-120"/>
                         </a:rPr>
-                        <a:t>Every chart in both workbooks now names its x and y axis</a:t>
+                        <a:t>Every chart in both workbooks now names its x and y axis; legends moved beside the plots so they no longer collide with the category labels</a:t>
+                      </a:r>
+                      <a:endParaRPr lang="en-US" sz="1050" dirty="0">
+                        <a:latin typeface="Calibri" charset="0"/>
+                        <a:ea typeface="Calibri" charset="0"/>
+                        <a:cs typeface="Calibri" charset="0"/>
+                      </a:endParaRPr>
+                    </a:p>
+                  </a:txBody>
+                  <a:tcPr marL="45720" marR="45720" marT="45720" marB="45720" anchor="ctr">
+                    <a:lnL w="6350" cap="flat" cmpd="sng" algn="ctr">
+                      <a:solidFill>
+                        <a:srgbClr val="C9C9C4"/>
+                      </a:solidFill>
+                      <a:prstDash val="solid"/>
+                      <a:round/>
+                      <a:headEnd type="none" w="med" len="med"/>
+                      <a:tailEnd type="none" w="med" len="med"/>
+                    </a:lnL>
+                    <a:lnR w="6350" cap="flat" cmpd="sng" algn="ctr">
+                      <a:solidFill>
+                        <a:srgbClr val="C9C9C4"/>
+                      </a:solidFill>
+                      <a:prstDash val="solid"/>
+                      <a:round/>
+                      <a:headEnd type="none" w="med" len="med"/>
+                      <a:tailEnd type="none" w="med" len="med"/>
+                    </a:lnR>
+                    <a:lnT w="6350" cap="flat" cmpd="sng" algn="ctr">
+                      <a:solidFill>
+                        <a:srgbClr val="C9C9C4"/>
+                      </a:solidFill>
+                      <a:prstDash val="solid"/>
+                      <a:round/>
+                      <a:headEnd type="none" w="med" len="med"/>
+                      <a:tailEnd type="none" w="med" len="med"/>
+                    </a:lnT>
+                    <a:lnB w="6350" cap="flat" cmpd="sng" algn="ctr">
+                      <a:solidFill>
+                        <a:srgbClr val="C9C9C4"/>
+                      </a:solidFill>
+                      <a:prstDash val="solid"/>
+                      <a:round/>
+                      <a:headEnd type="none" w="med" len="med"/>
+                      <a:tailEnd type="none" w="med" len="med"/>
+                    </a:lnB>
+                    <a:solidFill>
+                      <a:srgbClr val="FFFFFF"/>
+                    </a:solidFill>
+                  </a:tcPr>
+                </a:tc>
+              </a:tr>
+              <a:tr h="274320">
+                <a:tc>
+                  <a:txBody>
+                    <a:bodyPr/>
+                    <a:lstStyle/>
+                    <a:p>
+                      <a:pPr indent="0" marL="0">
+                        <a:buNone/>
+                      </a:pPr>
+                      <a:r>
+                        <a:rPr lang="en-US" sz="1050" dirty="0">
+                          <a:solidFill>
+                            <a:srgbClr val="1F1F1F"/>
+                          </a:solidFill>
+                          <a:latin typeface="Calibri" pitchFamily="34" charset="0"/>
+                          <a:ea typeface="Calibri" pitchFamily="34" charset="-122"/>
+                          <a:cs typeface="Calibri" pitchFamily="34" charset="-120"/>
+                        </a:rPr>
+                        <a:t>Summary layout</a:t>
+                      </a:r>
+                      <a:endParaRPr lang="en-US" sz="1050" dirty="0">
+                        <a:latin typeface="Calibri" charset="0"/>
+                        <a:ea typeface="Calibri" charset="0"/>
+                        <a:cs typeface="Calibri" charset="0"/>
+                      </a:endParaRPr>
+                    </a:p>
+                  </a:txBody>
+                  <a:tcPr marL="45720" marR="45720" marT="45720" marB="45720" anchor="ctr">
+                    <a:lnL w="6350" cap="flat" cmpd="sng" algn="ctr">
+                      <a:solidFill>
+                        <a:srgbClr val="C9C9C4"/>
+                      </a:solidFill>
+                      <a:prstDash val="solid"/>
+                      <a:round/>
+                      <a:headEnd type="none" w="med" len="med"/>
+                      <a:tailEnd type="none" w="med" len="med"/>
+                    </a:lnL>
+                    <a:lnR w="6350" cap="flat" cmpd="sng" algn="ctr">
+                      <a:solidFill>
+                        <a:srgbClr val="C9C9C4"/>
+                      </a:solidFill>
+                      <a:prstDash val="solid"/>
+                      <a:round/>
+                      <a:headEnd type="none" w="med" len="med"/>
+                      <a:tailEnd type="none" w="med" len="med"/>
+                    </a:lnR>
+                    <a:lnT w="6350" cap="flat" cmpd="sng" algn="ctr">
+                      <a:solidFill>
+                        <a:srgbClr val="C9C9C4"/>
+                      </a:solidFill>
+                      <a:prstDash val="solid"/>
+                      <a:round/>
+                      <a:headEnd type="none" w="med" len="med"/>
+                      <a:tailEnd type="none" w="med" len="med"/>
+                    </a:lnT>
+                    <a:lnB w="6350" cap="flat" cmpd="sng" algn="ctr">
+                      <a:solidFill>
+                        <a:srgbClr val="C9C9C4"/>
+                      </a:solidFill>
+                      <a:prstDash val="solid"/>
+                      <a:round/>
+                      <a:headEnd type="none" w="med" len="med"/>
+                      <a:tailEnd type="none" w="med" len="med"/>
+                    </a:lnB>
+                    <a:solidFill>
+                      <a:srgbClr val="FFFFFF"/>
+                    </a:solidFill>
+                  </a:tcPr>
+                </a:tc>
+                <a:tc>
+                  <a:txBody>
+                    <a:bodyPr/>
+                    <a:lstStyle/>
+                    <a:p>
+                      <a:pPr indent="0" marL="0">
+                        <a:buNone/>
+                      </a:pPr>
+                      <a:r>
+                        <a:rPr lang="en-US" sz="1050" dirty="0">
+                          <a:solidFill>
+                            <a:srgbClr val="1F1F1F"/>
+                          </a:solidFill>
+                          <a:latin typeface="Calibri" pitchFamily="34" charset="0"/>
+                          <a:ea typeface="Calibri" pitchFamily="34" charset="-122"/>
+                          <a:cs typeface="Calibri" pitchFamily="34" charset="-120"/>
+                        </a:rPr>
+                        <a:t>The duplicate table in columns A to F is hidden (the form still writes it), so the results table and the charts start at the left edge</a:t>
                       </a:r>
                       <a:endParaRPr lang="en-US" sz="1050" dirty="0">
                         <a:latin typeface="Calibri" charset="0"/>

</xml_diff>